<commit_message>
docs: reframe stakeholder briefing as secure by design
Shift messaging from leadership asks and rule-following to measurement,
detection, data-driven behaviour, and placing controls as what good
looks like.

Co-authored-by: Charlie Smith <casdev2020@users.noreply.github.com>
</commit_message>
<xml_diff>
--- a/docs/presentations/gitlab-compliance-stakeholder-briefing.pptx
+++ b/docs/presentations/gitlab-compliance-stakeholder-briefing.pptx
@@ -3258,7 +3258,7 @@
                 </a:solidFill>
                 <a:latin typeface="Calibri"/>
               </a:rPr>
-              <a:t>STAKEHOLDER BRIEFING</a:t>
+              <a:t>SECURE BY DESIGN</a:t>
             </a:r>
           </a:p>
         </p:txBody>
@@ -3272,7 +3272,7 @@
         <p:spPr>
           <a:xfrm>
             <a:off x="777240" y="1828800"/>
-            <a:ext cx="10515600" cy="1280160"/>
+            <a:ext cx="10515600" cy="1097280"/>
           </a:xfrm>
           <a:prstGeom prst="rect">
             <a:avLst/>
@@ -3306,8 +3306,8 @@
         </p:nvSpPr>
         <p:spPr>
           <a:xfrm>
-            <a:off x="777240" y="3108960"/>
-            <a:ext cx="10058400" cy="1097280"/>
+            <a:off x="777240" y="3063240"/>
+            <a:ext cx="10058400" cy="1188720"/>
           </a:xfrm>
           <a:prstGeom prst="rect">
             <a:avLst/>
@@ -3328,7 +3328,7 @@
                 </a:solidFill>
                 <a:latin typeface="Calibri"/>
               </a:rPr>
-              <a:t>Find delivery risk early, meet Nexus expectations, support the GitLab Dedicated move — and keep standards clear for everyone afterwards.</a:t>
+              <a:t>A way to measure, detect, and place controls in delivery pipelines — so Dedicated migration and Nexus expectations are guided by evidence, not assumption.</a:t>
             </a:r>
           </a:p>
         </p:txBody>
@@ -3367,7 +3367,7 @@
                 </a:solidFill>
                 <a:latin typeface="Calibri"/>
               </a:rPr>
-              <a:t>For delivery, security, and programme leaders</a:t>
+              <a:t>Measurement · Detection · Data-driven behaviour</a:t>
             </a:r>
           </a:p>
           <a:p>
@@ -3383,7 +3383,7 @@
                 </a:solidFill>
                 <a:latin typeface="Calibri"/>
               </a:rPr>
-              <a:t>Plain-language rules · clearer readiness · less last-minute surprise</a:t>
+              <a:t>Readable controls that stay in place after go-live</a:t>
             </a:r>
           </a:p>
         </p:txBody>
@@ -3600,7 +3600,7 @@
                 </a:solidFill>
                 <a:latin typeface="Calibri"/>
               </a:rPr>
-              <a:t>One approach serving migration and compliance together</a:t>
+              <a:t>Evidence-led readiness for Dedicated and Nexus</a:t>
             </a:r>
           </a:p>
         </p:txBody>
@@ -3635,7 +3635,7 @@
                 </a:solidFill>
                 <a:latin typeface="Calibri"/>
               </a:rPr>
-              <a:t>Gitlab Compliance  ·  Stakeholder briefing</a:t>
+              <a:t>Gitlab Compliance  ·  Secure by design</a:t>
             </a:r>
           </a:p>
         </p:txBody>
@@ -3791,7 +3791,7 @@
                 </a:solidFill>
                 <a:latin typeface="Calibri"/>
               </a:rPr>
-              <a:t>Need</a:t>
+              <a:t>Programme need</a:t>
             </a:r>
           </a:p>
         </p:txBody>
@@ -3826,7 +3826,7 @@
                 </a:solidFill>
                 <a:latin typeface="Calibri"/>
               </a:rPr>
-              <a:t>How Gitlab Compliance helps</a:t>
+              <a:t>Secure-by-design response</a:t>
             </a:r>
           </a:p>
         </p:txBody>
@@ -3947,7 +3947,7 @@
                 </a:solidFill>
                 <a:latin typeface="Calibri"/>
               </a:rPr>
-              <a:t>Know readiness before Dedicated cutover</a:t>
+              <a:t>Know control coverage before Dedicated cutover</a:t>
             </a:r>
           </a:p>
         </p:txBody>
@@ -3982,7 +3982,7 @@
                 </a:solidFill>
                 <a:latin typeface="Calibri"/>
               </a:rPr>
-              <a:t>Ranked risk view across the migration cohort</a:t>
+              <a:t>Measured baseline across the migration cohort</a:t>
             </a:r>
           </a:p>
         </p:txBody>
@@ -4138,7 +4138,7 @@
                 </a:solidFill>
                 <a:latin typeface="Calibri"/>
               </a:rPr>
-              <a:t>Checks and fixes for trusted, up-to-date components</a:t>
+              <a:t>Detectable pinning and freshness controls</a:t>
             </a:r>
           </a:p>
         </p:txBody>
@@ -4259,7 +4259,7 @@
                 </a:solidFill>
                 <a:latin typeface="Calibri"/>
               </a:rPr>
-              <a:t>Reduce last-minute surprise</a:t>
+              <a:t>Reduce late surprise</a:t>
             </a:r>
           </a:p>
         </p:txBody>
@@ -4294,7 +4294,7 @@
                 </a:solidFill>
                 <a:latin typeface="Calibri"/>
               </a:rPr>
-              <a:t>Issues found and discussed before go-live pressure</a:t>
+              <a:t>Gaps detected early enough to place controls calmly</a:t>
             </a:r>
           </a:p>
         </p:txBody>
@@ -4415,7 +4415,7 @@
                 </a:solidFill>
                 <a:latin typeface="Calibri"/>
               </a:rPr>
-              <a:t>Give leaders usable evidence</a:t>
+              <a:t>Decide with data</a:t>
             </a:r>
           </a:p>
         </p:txBody>
@@ -4450,7 +4450,7 @@
                 </a:solidFill>
                 <a:latin typeface="Calibri"/>
               </a:rPr>
-              <a:t>Clear reports and summaries for decision forums</a:t>
+              <a:t>Shared reports replace assumption-based status</a:t>
             </a:r>
           </a:p>
         </p:txBody>
@@ -4571,7 +4571,7 @@
                 </a:solidFill>
                 <a:latin typeface="Calibri"/>
               </a:rPr>
-              <a:t>Keep standards after the move</a:t>
+              <a:t>Keep controls after the move</a:t>
             </a:r>
           </a:p>
         </p:txBody>
@@ -4606,7 +4606,7 @@
                 </a:solidFill>
                 <a:latin typeface="Calibri"/>
               </a:rPr>
-              <a:t>Readable policies remain the ongoing contract</a:t>
+              <a:t>Readable policies remain the ongoing design contract</a:t>
             </a:r>
           </a:p>
         </p:txBody>
@@ -4823,7 +4823,7 @@
                 </a:solidFill>
                 <a:latin typeface="Calibri"/>
               </a:rPr>
-              <a:t>Simple measures for programme confidence</a:t>
+              <a:t>Controls identified, placed, and continuously detectable</a:t>
             </a:r>
           </a:p>
         </p:txBody>
@@ -4858,7 +4858,7 @@
                 </a:solidFill>
                 <a:latin typeface="Calibri"/>
               </a:rPr>
-              <a:t>Gitlab Compliance  ·  Stakeholder briefing</a:t>
+              <a:t>Gitlab Compliance  ·  Secure by design</a:t>
             </a:r>
           </a:p>
         </p:txBody>
@@ -4950,7 +4950,7 @@
         <p:spPr>
           <a:xfrm>
             <a:off x="731520" y="1828800"/>
-            <a:ext cx="3200400" cy="411480"/>
+            <a:ext cx="3200400" cy="457200"/>
           </a:xfrm>
           <a:prstGeom prst="rect">
             <a:avLst/>
@@ -4965,13 +4965,13 @@
           <a:p>
             <a:pPr algn="l"/>
             <a:r>
-              <a:rPr sz="1600" b="1">
+              <a:rPr sz="1500" b="1">
                 <a:solidFill>
                   <a:srgbClr val="1A6B63"/>
                 </a:solidFill>
                 <a:latin typeface="Calibri"/>
               </a:rPr>
-              <a:t>Coverage</a:t>
+              <a:t>Controls identified</a:t>
             </a:r>
           </a:p>
         </p:txBody>
@@ -4985,7 +4985,7 @@
         <p:spPr>
           <a:xfrm>
             <a:off x="731520" y="2377440"/>
-            <a:ext cx="3200400" cy="822960"/>
+            <a:ext cx="3200400" cy="868680"/>
           </a:xfrm>
           <a:prstGeom prst="rect">
             <a:avLst/>
@@ -5006,7 +5006,7 @@
                 </a:solidFill>
                 <a:latin typeface="Calibri"/>
               </a:rPr>
-              <a:t>Most migration projects have been reviewed against the standard.</a:t>
+              <a:t>Intended controls are defined in plain language for each risk area.</a:t>
             </a:r>
           </a:p>
         </p:txBody>
@@ -5063,7 +5063,7 @@
         <p:spPr>
           <a:xfrm>
             <a:off x="4572000" y="1828800"/>
-            <a:ext cx="3200400" cy="411480"/>
+            <a:ext cx="3200400" cy="457200"/>
           </a:xfrm>
           <a:prstGeom prst="rect">
             <a:avLst/>
@@ -5078,13 +5078,13 @@
           <a:p>
             <a:pPr algn="l"/>
             <a:r>
-              <a:rPr sz="1600" b="1">
+              <a:rPr sz="1500" b="1">
                 <a:solidFill>
                   <a:srgbClr val="1A6B63"/>
                 </a:solidFill>
                 <a:latin typeface="Calibri"/>
               </a:rPr>
-              <a:t>Open issues falling</a:t>
+              <a:t>Controls placed</a:t>
             </a:r>
           </a:p>
         </p:txBody>
@@ -5098,7 +5098,7 @@
         <p:spPr>
           <a:xfrm>
             <a:off x="4572000" y="2377440"/>
-            <a:ext cx="3200400" cy="822960"/>
+            <a:ext cx="3200400" cy="868680"/>
           </a:xfrm>
           <a:prstGeom prst="rect">
             <a:avLst/>
@@ -5119,7 +5119,7 @@
                 </a:solidFill>
                 <a:latin typeface="Calibri"/>
               </a:rPr>
-              <a:t>Critical gaps are tracked and trending down.</a:t>
+              <a:t>Those controls are applied in delivery pipelines, not only described.</a:t>
             </a:r>
           </a:p>
         </p:txBody>
@@ -5176,7 +5176,7 @@
         <p:spPr>
           <a:xfrm>
             <a:off x="8412480" y="1828800"/>
-            <a:ext cx="3200400" cy="411480"/>
+            <a:ext cx="3200400" cy="457200"/>
           </a:xfrm>
           <a:prstGeom prst="rect">
             <a:avLst/>
@@ -5191,13 +5191,13 @@
           <a:p>
             <a:pPr algn="l"/>
             <a:r>
-              <a:rPr sz="1600" b="1">
+              <a:rPr sz="1500" b="1">
                 <a:solidFill>
                   <a:srgbClr val="1A6B63"/>
                 </a:solidFill>
                 <a:latin typeface="Calibri"/>
               </a:rPr>
-              <a:t>Faster fixes</a:t>
+              <a:t>Detection active</a:t>
             </a:r>
           </a:p>
         </p:txBody>
@@ -5211,7 +5211,7 @@
         <p:spPr>
           <a:xfrm>
             <a:off x="8412480" y="2377440"/>
-            <a:ext cx="3200400" cy="822960"/>
+            <a:ext cx="3200400" cy="868680"/>
           </a:xfrm>
           <a:prstGeom prst="rect">
             <a:avLst/>
@@ -5232,7 +5232,7 @@
                 </a:solidFill>
                 <a:latin typeface="Calibri"/>
               </a:rPr>
-              <a:t>Time from finding to approved fix is shortening.</a:t>
+              <a:t>Gaps are spotted automatically before approval.</a:t>
             </a:r>
           </a:p>
         </p:txBody>
@@ -5289,7 +5289,7 @@
         <p:spPr>
           <a:xfrm>
             <a:off x="731520" y="4023360"/>
-            <a:ext cx="3200400" cy="411480"/>
+            <a:ext cx="3200400" cy="457200"/>
           </a:xfrm>
           <a:prstGeom prst="rect">
             <a:avLst/>
@@ -5304,13 +5304,13 @@
           <a:p>
             <a:pPr algn="l"/>
             <a:r>
-              <a:rPr sz="1600" b="1">
+              <a:rPr sz="1500" b="1">
                 <a:solidFill>
                   <a:srgbClr val="1A6B63"/>
                 </a:solidFill>
                 <a:latin typeface="Calibri"/>
               </a:rPr>
-              <a:t>Clear explanations</a:t>
+              <a:t>Measurement shared</a:t>
             </a:r>
           </a:p>
         </p:txBody>
@@ -5324,7 +5324,7 @@
         <p:spPr>
           <a:xfrm>
             <a:off x="731520" y="4572000"/>
-            <a:ext cx="3200400" cy="822960"/>
+            <a:ext cx="3200400" cy="868680"/>
           </a:xfrm>
           <a:prstGeom prst="rect">
             <a:avLst/>
@@ -5345,7 +5345,7 @@
                 </a:solidFill>
                 <a:latin typeface="Calibri"/>
               </a:rPr>
-              <a:t>Teams can explain a finding without specialist decoding.</a:t>
+              <a:t>Coverage and findings are visible in a common evidence view.</a:t>
             </a:r>
           </a:p>
         </p:txBody>
@@ -5402,7 +5402,7 @@
         <p:spPr>
           <a:xfrm>
             <a:off x="4572000" y="4023360"/>
-            <a:ext cx="3200400" cy="411480"/>
+            <a:ext cx="3200400" cy="457200"/>
           </a:xfrm>
           <a:prstGeom prst="rect">
             <a:avLst/>
@@ -5417,13 +5417,13 @@
           <a:p>
             <a:pPr algn="l"/>
             <a:r>
-              <a:rPr sz="1600" b="1">
+              <a:rPr sz="1500" b="1">
                 <a:solidFill>
                   <a:srgbClr val="1A6B63"/>
                 </a:solidFill>
                 <a:latin typeface="Calibri"/>
               </a:rPr>
-              <a:t>Ready evidence</a:t>
+              <a:t>Data-driven improvement</a:t>
             </a:r>
           </a:p>
         </p:txBody>
@@ -5437,7 +5437,7 @@
         <p:spPr>
           <a:xfrm>
             <a:off x="4572000" y="4572000"/>
-            <a:ext cx="3200400" cy="822960"/>
+            <a:ext cx="3200400" cy="868680"/>
           </a:xfrm>
           <a:prstGeom prst="rect">
             <a:avLst/>
@@ -5458,7 +5458,7 @@
                 </a:solidFill>
                 <a:latin typeface="Calibri"/>
               </a:rPr>
-              <a:t>Readiness packs include current summaries and reports.</a:t>
+              <a:t>Priorities follow measured gap severity, not anecdote.</a:t>
             </a:r>
           </a:p>
         </p:txBody>
@@ -5515,7 +5515,7 @@
         <p:spPr>
           <a:xfrm>
             <a:off x="8412480" y="4023360"/>
-            <a:ext cx="3200400" cy="411480"/>
+            <a:ext cx="3200400" cy="457200"/>
           </a:xfrm>
           <a:prstGeom prst="rect">
             <a:avLst/>
@@ -5530,13 +5530,13 @@
           <a:p>
             <a:pPr algn="l"/>
             <a:r>
-              <a:rPr sz="1600" b="1">
+              <a:rPr sz="1500" b="1">
                 <a:solidFill>
                   <a:srgbClr val="1A6B63"/>
                 </a:solidFill>
                 <a:latin typeface="Calibri"/>
               </a:rPr>
-              <a:t>Standards stick</a:t>
+              <a:t>Secure by design sustained</a:t>
             </a:r>
           </a:p>
         </p:txBody>
@@ -5550,7 +5550,7 @@
         <p:spPr>
           <a:xfrm>
             <a:off x="8412480" y="4572000"/>
-            <a:ext cx="3200400" cy="822960"/>
+            <a:ext cx="3200400" cy="868680"/>
           </a:xfrm>
           <a:prstGeom prst="rect">
             <a:avLst/>
@@ -5571,7 +5571,7 @@
                 </a:solidFill>
                 <a:latin typeface="Calibri"/>
               </a:rPr>
-              <a:t>The same rules still protect delivery after cutover.</a:t>
+              <a:t>The same controls remain detectable after Dedicated cutover.</a:t>
             </a:r>
           </a:p>
         </p:txBody>
@@ -5704,13 +5704,13 @@
           <a:p>
             <a:pPr algn="l"/>
             <a:r>
-              <a:rPr sz="3400" b="1">
+              <a:rPr sz="3000" b="1">
                 <a:solidFill>
                   <a:srgbClr val="FFFFFF"/>
                 </a:solidFill>
                 <a:latin typeface="Calibri"/>
               </a:rPr>
-              <a:t>The ask</a:t>
+              <a:t>Secure by design in practice</a:t>
             </a:r>
           </a:p>
         </p:txBody>
@@ -5749,7 +5749,7 @@
                 </a:solidFill>
                 <a:latin typeface="Calibri"/>
               </a:rPr>
-              <a:t>1.  Endorse a readiness scan of the Dedicated migration cohort</a:t>
+              <a:t>1.  Define the controls that matter for Dedicated readiness and Nexus assurance</a:t>
             </a:r>
           </a:p>
           <a:p>
@@ -5765,7 +5765,7 @@
                 </a:solidFill>
                 <a:latin typeface="Calibri"/>
               </a:rPr>
-              <a:t>2.  Agree that Nexus-related standards will be written in plain language and checked before approval</a:t>
+              <a:t>2.  Measure where those controls are already in place across the cohort</a:t>
             </a:r>
           </a:p>
           <a:p>
@@ -5781,7 +5781,7 @@
                 </a:solidFill>
                 <a:latin typeface="Calibri"/>
               </a:rPr>
-              <a:t>3.  Support a warn-first approach, then strengthen once the baseline is clean</a:t>
+              <a:t>3.  Detect remaining gaps early and place controls with reviewable change</a:t>
             </a:r>
           </a:p>
           <a:p>
@@ -5797,7 +5797,7 @@
                 </a:solidFill>
                 <a:latin typeface="Calibri"/>
               </a:rPr>
-              <a:t>4.  Use the reports in programme forums as the shared view of risk and progress</a:t>
+              <a:t>4.  Use shared evidence to prioritise and track improvement</a:t>
             </a:r>
           </a:p>
           <a:p>
@@ -5813,7 +5813,7 @@
                 </a:solidFill>
                 <a:latin typeface="Calibri"/>
               </a:rPr>
-              <a:t>5.  Confirm that the same readable standards remain in force after cutover</a:t>
+              <a:t>5.  Keep readable policies as the ongoing design standard after go-live</a:t>
             </a:r>
           </a:p>
         </p:txBody>
@@ -5848,7 +5848,7 @@
                 </a:solidFill>
                 <a:latin typeface="Calibri"/>
               </a:rPr>
-              <a:t>Outcome: fewer surprises, clearer ownership, and standards that stay understandable.</a:t>
+              <a:t>What good looks like: controls identified, placed, measured, and continuously detectable.</a:t>
             </a:r>
           </a:p>
         </p:txBody>
@@ -6065,7 +6065,7 @@
                 </a:solidFill>
                 <a:latin typeface="Calibri"/>
               </a:rPr>
-              <a:t>Outcomes first — not tooling detail</a:t>
+              <a:t>Secure by design — measured and detectable</a:t>
             </a:r>
           </a:p>
         </p:txBody>
@@ -6100,7 +6100,7 @@
                 </a:solidFill>
                 <a:latin typeface="Calibri"/>
               </a:rPr>
-              <a:t>Gitlab Compliance  ·  Stakeholder briefing</a:t>
+              <a:t>Gitlab Compliance  ·  Secure by design</a:t>
             </a:r>
           </a:p>
         </p:txBody>
@@ -6174,7 +6174,7 @@
                 </a:solidFill>
                 <a:latin typeface="Calibri"/>
               </a:rPr>
-              <a:t>1.  The problem we are solving</a:t>
+              <a:t>1.  Why delivery needs measurable controls</a:t>
             </a:r>
           </a:p>
           <a:p>
@@ -6190,7 +6190,7 @@
                 </a:solidFill>
                 <a:latin typeface="Calibri"/>
               </a:rPr>
-              <a:t>2.  Why it matters for Dedicated and Nexus</a:t>
+              <a:t>2.  Dedicated migration and Nexus as design moments</a:t>
             </a:r>
           </a:p>
           <a:p>
@@ -6206,7 +6206,7 @@
                 </a:solidFill>
                 <a:latin typeface="Calibri"/>
               </a:rPr>
-              <a:t>3.  What Gitlab Compliance does in plain terms</a:t>
+              <a:t>3.  What Gitlab Compliance enables</a:t>
             </a:r>
           </a:p>
           <a:p>
@@ -6222,7 +6222,7 @@
                 </a:solidFill>
                 <a:latin typeface="Calibri"/>
               </a:rPr>
-              <a:t>4.  How we find and fix delivery risk</a:t>
+              <a:t>4.  Where controls are identified and placed</a:t>
             </a:r>
           </a:p>
           <a:p>
@@ -6238,7 +6238,7 @@
                 </a:solidFill>
                 <a:latin typeface="Calibri"/>
               </a:rPr>
-              <a:t>5.  How easy-to-read policies keep standards ongoing</a:t>
+              <a:t>5.  Readable policies that keep standards ongoing</a:t>
             </a:r>
           </a:p>
           <a:p>
@@ -6254,7 +6254,7 @@
                 </a:solidFill>
                 <a:latin typeface="Calibri"/>
               </a:rPr>
-              <a:t>6.  What good looks like — and the ask</a:t>
+              <a:t>6.  What good looks like</a:t>
             </a:r>
           </a:p>
         </p:txBody>
@@ -6436,7 +6436,7 @@
                 </a:solidFill>
                 <a:latin typeface="Calibri"/>
               </a:rPr>
-              <a:t>The problem</a:t>
+              <a:t>The design gap</a:t>
             </a:r>
           </a:p>
         </p:txBody>
@@ -6471,7 +6471,7 @@
                 </a:solidFill>
                 <a:latin typeface="Calibri"/>
               </a:rPr>
-              <a:t>Important delivery rules are easy to miss until something breaks</a:t>
+              <a:t>Without measurement, control gaps stay invisible until late</a:t>
             </a:r>
           </a:p>
         </p:txBody>
@@ -6506,7 +6506,7 @@
                 </a:solidFill>
                 <a:latin typeface="Calibri"/>
               </a:rPr>
-              <a:t>Gitlab Compliance  ·  Stakeholder briefing</a:t>
+              <a:t>Gitlab Compliance  ·  Secure by design</a:t>
             </a:r>
           </a:p>
         </p:txBody>
@@ -6662,7 +6662,7 @@
                 </a:solidFill>
                 <a:latin typeface="Calibri"/>
               </a:rPr>
-              <a:t>Hidden risk</a:t>
+              <a:t>Hard to measure</a:t>
             </a:r>
           </a:p>
         </p:txBody>
@@ -6697,7 +6697,7 @@
                 </a:solidFill>
                 <a:latin typeface="Calibri"/>
               </a:rPr>
-              <a:t>Build and release setups can quietly drift from agreed standards.</a:t>
+              <a:t>We cannot see which delivery setups meet the intended control standard.</a:t>
             </a:r>
           </a:p>
         </p:txBody>
@@ -6818,7 +6818,7 @@
                 </a:solidFill>
                 <a:latin typeface="Calibri"/>
               </a:rPr>
-              <a:t>Late discovery</a:t>
+              <a:t>Hard to detect</a:t>
             </a:r>
           </a:p>
         </p:txBody>
@@ -6853,7 +6853,7 @@
                 </a:solidFill>
                 <a:latin typeface="Calibri"/>
               </a:rPr>
-              <a:t>Issues often show up close to go-live — when change is costly.</a:t>
+              <a:t>Gaps appear late — often near go-live — when change is expensive.</a:t>
             </a:r>
           </a:p>
         </p:txBody>
@@ -6974,7 +6974,7 @@
                 </a:solidFill>
                 <a:latin typeface="Calibri"/>
               </a:rPr>
-              <a:t>Hard to explain</a:t>
+              <a:t>Hard to place controls</a:t>
             </a:r>
           </a:p>
         </p:txBody>
@@ -7009,7 +7009,7 @@
                 </a:solidFill>
                 <a:latin typeface="Calibri"/>
               </a:rPr>
-              <a:t>Rules live in long technical files that few people can review with confidence.</a:t>
+              <a:t>Expectations exist in guidance, but are not consistently applied in pipelines.</a:t>
             </a:r>
           </a:p>
         </p:txBody>
@@ -7130,7 +7130,7 @@
                 </a:solidFill>
                 <a:latin typeface="Calibri"/>
               </a:rPr>
-              <a:t>Uneven practice</a:t>
+              <a:t>Hard to decide with data</a:t>
             </a:r>
           </a:p>
         </p:txBody>
@@ -7165,7 +7165,7 @@
                 </a:solidFill>
                 <a:latin typeface="Calibri"/>
               </a:rPr>
-              <a:t>Some teams follow the rules; others do not — and leaders cannot see the gap.</a:t>
+              <a:t>Progress relies on anecdotes instead of a shared, evidence-based view.</a:t>
             </a:r>
           </a:p>
         </p:txBody>
@@ -7382,7 +7382,7 @@
                 </a:solidFill>
                 <a:latin typeface="Calibri"/>
               </a:rPr>
-              <a:t>Two programmes that make invisible risk visible</a:t>
+              <a:t>Two moments to design security into delivery — not bolt it on later</a:t>
             </a:r>
           </a:p>
         </p:txBody>
@@ -7417,7 +7417,7 @@
                 </a:solidFill>
                 <a:latin typeface="Calibri"/>
               </a:rPr>
-              <a:t>Gitlab Compliance  ·  Stakeholder briefing</a:t>
+              <a:t>Gitlab Compliance  ·  Secure by design</a:t>
             </a:r>
           </a:p>
         </p:txBody>
@@ -7612,7 +7612,7 @@
                 </a:solidFill>
                 <a:latin typeface="Calibri"/>
               </a:rPr>
-              <a:t>We need a clear picture of delivery readiness before cutover</a:t>
+              <a:t>Cutover is a chance to baseline control coverage</a:t>
             </a:r>
           </a:p>
           <a:p>
@@ -7628,7 +7628,7 @@
                 </a:solidFill>
                 <a:latin typeface="Calibri"/>
               </a:rPr>
-              <a:t>Unknown debt turns into schedule risk</a:t>
+              <a:t>Unknown gaps become schedule and service risk</a:t>
             </a:r>
           </a:p>
           <a:p>
@@ -7644,7 +7644,7 @@
                 </a:solidFill>
                 <a:latin typeface="Calibri"/>
               </a:rPr>
-              <a:t>Leaders need simple evidence — not technical archaeology</a:t>
+              <a:t>Readiness should be evidenced, not assumed</a:t>
             </a:r>
           </a:p>
           <a:p>
@@ -7660,7 +7660,7 @@
                 </a:solidFill>
                 <a:latin typeface="Calibri"/>
               </a:rPr>
-              <a:t>Better to fix early than discover during migration</a:t>
+              <a:t>Secure by design means controls are in place before the move</a:t>
             </a:r>
           </a:p>
         </p:txBody>
@@ -7820,7 +7820,7 @@
                 </a:solidFill>
                 <a:latin typeface="Calibri"/>
               </a:rPr>
-              <a:t>Approved, trusted components become mandatory</a:t>
+              <a:t>Trusted, approved components need detectable controls</a:t>
             </a:r>
           </a:p>
           <a:p>
@@ -7836,7 +7836,7 @@
                 </a:solidFill>
                 <a:latin typeface="Calibri"/>
               </a:rPr>
-              <a:t>Loose or outdated dependencies create control gaps</a:t>
+              <a:t>Freshness and pinning expectations must be measurable</a:t>
             </a:r>
           </a:p>
           <a:p>
@@ -7852,7 +7852,7 @@
                 </a:solidFill>
                 <a:latin typeface="Calibri"/>
               </a:rPr>
-              <a:t>We need proof that standards are followed</a:t>
+              <a:t>Evidence of control effectiveness supports assurance</a:t>
             </a:r>
           </a:p>
           <a:p>
@@ -7868,7 +7868,7 @@
                 </a:solidFill>
                 <a:latin typeface="Calibri"/>
               </a:rPr>
-              <a:t>Fixes must be reviewable and sustainable</a:t>
+              <a:t>Remediation stays reviewable and sustainable</a:t>
             </a:r>
           </a:p>
         </p:txBody>
@@ -8050,7 +8050,7 @@
                 </a:solidFill>
                 <a:latin typeface="Calibri"/>
               </a:rPr>
-              <a:t>What Gitlab Compliance does</a:t>
+              <a:t>What Gitlab Compliance enables</a:t>
             </a:r>
           </a:p>
         </p:txBody>
@@ -8085,7 +8085,7 @@
                 </a:solidFill>
                 <a:latin typeface="Calibri"/>
               </a:rPr>
-              <a:t>A practical way to check delivery setups against agreed standards</a:t>
+              <a:t>A measurement and detection layer for delivery controls</a:t>
             </a:r>
           </a:p>
         </p:txBody>
@@ -8120,7 +8120,7 @@
                 </a:solidFill>
                 <a:latin typeface="Calibri"/>
               </a:rPr>
-              <a:t>Gitlab Compliance  ·  Stakeholder briefing</a:t>
+              <a:t>Gitlab Compliance  ·  Secure by design</a:t>
             </a:r>
           </a:p>
         </p:txBody>
@@ -8190,7 +8190,7 @@
                 </a:solidFill>
                 <a:latin typeface="Calibri"/>
               </a:rPr>
-              <a:t>It checks how teams build and release software — before changes are approved — and highlights where practice does not match the standard.</a:t>
+              <a:t>It turns agreed security expectations into detectable signals — so teams can place controls early and improve based on data.</a:t>
             </a:r>
           </a:p>
         </p:txBody>
@@ -8311,7 +8311,7 @@
                 </a:solidFill>
                 <a:latin typeface="Calibri"/>
               </a:rPr>
-              <a:t>Find issues early</a:t>
+              <a:t>Measure</a:t>
             </a:r>
           </a:p>
         </p:txBody>
@@ -8346,7 +8346,7 @@
                 </a:solidFill>
                 <a:latin typeface="Calibri"/>
               </a:rPr>
-              <a:t>Spot delivery risk while there is still time to fix it.</a:t>
+              <a:t>See where intended controls are present or missing across projects.</a:t>
             </a:r>
           </a:p>
         </p:txBody>
@@ -8467,7 +8467,7 @@
                 </a:solidFill>
                 <a:latin typeface="Calibri"/>
               </a:rPr>
-              <a:t>Speak plainly</a:t>
+              <a:t>Detect</a:t>
             </a:r>
           </a:p>
         </p:txBody>
@@ -8502,7 +8502,7 @@
                 </a:solidFill>
                 <a:latin typeface="Calibri"/>
               </a:rPr>
-              <a:t>Standards are written in everyday language teams can share.</a:t>
+              <a:t>Surface gaps before approval — while change is still low-cost.</a:t>
             </a:r>
           </a:p>
         </p:txBody>
@@ -8623,7 +8623,7 @@
                 </a:solidFill>
                 <a:latin typeface="Calibri"/>
               </a:rPr>
-              <a:t>Show the evidence</a:t>
+              <a:t>Guide behaviour</a:t>
             </a:r>
           </a:p>
         </p:txBody>
@@ -8658,7 +8658,7 @@
                 </a:solidFill>
                 <a:latin typeface="Calibri"/>
               </a:rPr>
-              <a:t>Clear reports for programme, security, and delivery forums.</a:t>
+              <a:t>Shared evidence supports consistent, data-driven decisions.</a:t>
             </a:r>
           </a:p>
         </p:txBody>
@@ -8779,7 +8779,7 @@
                 </a:solidFill>
                 <a:latin typeface="Calibri"/>
               </a:rPr>
-              <a:t>Help fix what matters</a:t>
+              <a:t>Place controls</a:t>
             </a:r>
           </a:p>
         </p:txBody>
@@ -8814,7 +8814,7 @@
                 </a:solidFill>
                 <a:latin typeface="Calibri"/>
               </a:rPr>
-              <a:t>Guided remediations reduce the backlog of known debt.</a:t>
+              <a:t>Readable policies define the control; checks confirm it is applied.</a:t>
             </a:r>
           </a:p>
         </p:txBody>
@@ -8935,7 +8935,7 @@
                 </a:solidFill>
                 <a:latin typeface="Calibri"/>
               </a:rPr>
-              <a:t>Keep knowledge current</a:t>
+              <a:t>Strengthen supply chain</a:t>
             </a:r>
           </a:p>
         </p:txBody>
@@ -8970,7 +8970,7 @@
                 </a:solidFill>
                 <a:latin typeface="Calibri"/>
               </a:rPr>
-              <a:t>Living summaries of how pipelines actually work.</a:t>
+              <a:t>Pinning and freshness controls align with Nexus expectations.</a:t>
             </a:r>
           </a:p>
         </p:txBody>
@@ -9091,7 +9091,7 @@
                 </a:solidFill>
                 <a:latin typeface="Calibri"/>
               </a:rPr>
-              <a:t>Stay consistent</a:t>
+              <a:t>Keep visibility</a:t>
             </a:r>
           </a:p>
         </p:txBody>
@@ -9126,7 +9126,7 @@
                 </a:solidFill>
                 <a:latin typeface="Calibri"/>
               </a:rPr>
-              <a:t>The same standard applies across teams and projects.</a:t>
+              <a:t>Living summaries make pipeline intent understandable over time.</a:t>
             </a:r>
           </a:p>
         </p:txBody>
@@ -9308,7 +9308,7 @@
                 </a:solidFill>
                 <a:latin typeface="Calibri"/>
               </a:rPr>
-              <a:t>How we use it</a:t>
+              <a:t>How the tool supports secure by design</a:t>
             </a:r>
           </a:p>
         </p:txBody>
@@ -9343,7 +9343,7 @@
                 </a:solidFill>
                 <a:latin typeface="Calibri"/>
               </a:rPr>
-              <a:t>Four simple activities — one outcome: fewer surprises</a:t>
+              <a:t>Four capabilities that make controls measurable</a:t>
             </a:r>
           </a:p>
         </p:txBody>
@@ -9378,7 +9378,7 @@
                 </a:solidFill>
                 <a:latin typeface="Calibri"/>
               </a:rPr>
-              <a:t>Gitlab Compliance  ·  Stakeholder briefing</a:t>
+              <a:t>Gitlab Compliance  ·  Secure by design</a:t>
             </a:r>
           </a:p>
         </p:txBody>
@@ -9470,7 +9470,7 @@
         <p:spPr>
           <a:xfrm>
             <a:off x="594360" y="1417320"/>
-            <a:ext cx="2377440" cy="987552"/>
+            <a:ext cx="2560320" cy="987552"/>
           </a:xfrm>
           <a:prstGeom prst="rect">
             <a:avLst/>
@@ -9513,7 +9513,7 @@
         <p:spPr>
           <a:xfrm>
             <a:off x="685800" y="1709928"/>
-            <a:ext cx="2194560" cy="411480"/>
+            <a:ext cx="2377440" cy="411480"/>
           </a:xfrm>
           <a:prstGeom prst="rect">
             <a:avLst/>
@@ -9528,7 +9528,7 @@
           <a:p>
             <a:pPr algn="ctr"/>
             <a:r>
-              <a:rPr sz="1500" b="1">
+              <a:rPr sz="1400" b="1">
                 <a:solidFill>
                   <a:srgbClr val="FFFFFF"/>
                 </a:solidFill>
@@ -9547,8 +9547,8 @@
         </p:nvSpPr>
         <p:spPr>
           <a:xfrm>
-            <a:off x="3200400" y="1691640"/>
-            <a:ext cx="8046720" cy="502920"/>
+            <a:off x="3383280" y="1691640"/>
+            <a:ext cx="7863840" cy="502920"/>
           </a:xfrm>
           <a:prstGeom prst="rect">
             <a:avLst/>
@@ -9569,7 +9569,7 @@
                 </a:solidFill>
                 <a:latin typeface="Calibri"/>
               </a:rPr>
-              <a:t>Compare each project against the agreed standard and list what needs attention.</a:t>
+              <a:t>Detect whether each project meets the intended control standard.</a:t>
             </a:r>
           </a:p>
         </p:txBody>
@@ -9626,7 +9626,7 @@
         <p:spPr>
           <a:xfrm>
             <a:off x="594360" y="2514600"/>
-            <a:ext cx="2377440" cy="987552"/>
+            <a:ext cx="2560320" cy="987552"/>
           </a:xfrm>
           <a:prstGeom prst="rect">
             <a:avLst/>
@@ -9669,7 +9669,7 @@
         <p:spPr>
           <a:xfrm>
             <a:off x="685800" y="2807208"/>
-            <a:ext cx="2194560" cy="411480"/>
+            <a:ext cx="2377440" cy="411480"/>
           </a:xfrm>
           <a:prstGeom prst="rect">
             <a:avLst/>
@@ -9684,7 +9684,7 @@
           <a:p>
             <a:pPr algn="ctr"/>
             <a:r>
-              <a:rPr sz="1500" b="1">
+              <a:rPr sz="1400" b="1">
                 <a:solidFill>
                   <a:srgbClr val="FFFFFF"/>
                 </a:solidFill>
@@ -9703,8 +9703,8 @@
         </p:nvSpPr>
         <p:spPr>
           <a:xfrm>
-            <a:off x="3200400" y="2788920"/>
-            <a:ext cx="8046720" cy="502920"/>
+            <a:off x="3383280" y="2788920"/>
+            <a:ext cx="7863840" cy="502920"/>
           </a:xfrm>
           <a:prstGeom prst="rect">
             <a:avLst/>
@@ -9725,7 +9725,7 @@
                 </a:solidFill>
                 <a:latin typeface="Calibri"/>
               </a:rPr>
-              <a:t>Review many projects quickly so the migration cohort has a ranked risk view.</a:t>
+              <a:t>Measure coverage across the migration cohort with a shared risk view.</a:t>
             </a:r>
           </a:p>
         </p:txBody>
@@ -9782,7 +9782,7 @@
         <p:spPr>
           <a:xfrm>
             <a:off x="594360" y="3611880"/>
-            <a:ext cx="2377440" cy="987552"/>
+            <a:ext cx="2560320" cy="987552"/>
           </a:xfrm>
           <a:prstGeom prst="rect">
             <a:avLst/>
@@ -9825,7 +9825,7 @@
         <p:spPr>
           <a:xfrm>
             <a:off x="685800" y="3904488"/>
-            <a:ext cx="2194560" cy="411480"/>
+            <a:ext cx="2377440" cy="411480"/>
           </a:xfrm>
           <a:prstGeom prst="rect">
             <a:avLst/>
@@ -9840,13 +9840,13 @@
           <a:p>
             <a:pPr algn="ctr"/>
             <a:r>
-              <a:rPr sz="1500" b="1">
+              <a:rPr sz="1400" b="1">
                 <a:solidFill>
                   <a:srgbClr val="FFFFFF"/>
                 </a:solidFill>
                 <a:latin typeface="Calibri"/>
               </a:rPr>
-              <a:t>Strengthen supply chain</a:t>
+              <a:t>Supply-chain controls</a:t>
             </a:r>
           </a:p>
         </p:txBody>
@@ -9859,8 +9859,8 @@
         </p:nvSpPr>
         <p:spPr>
           <a:xfrm>
-            <a:off x="3200400" y="3886200"/>
-            <a:ext cx="8046720" cy="502920"/>
+            <a:off x="3383280" y="3886200"/>
+            <a:ext cx="7863840" cy="502920"/>
           </a:xfrm>
           <a:prstGeom prst="rect">
             <a:avLst/>
@@ -9881,7 +9881,7 @@
                 </a:solidFill>
                 <a:latin typeface="Calibri"/>
               </a:rPr>
-              <a:t>Tighten use of trusted components and close known gaps against Nexus expectations.</a:t>
+              <a:t>Place pinning and freshness controls that support Nexus expectations.</a:t>
             </a:r>
           </a:p>
         </p:txBody>
@@ -9938,7 +9938,7 @@
         <p:spPr>
           <a:xfrm>
             <a:off x="594360" y="4709159"/>
-            <a:ext cx="2377440" cy="987552"/>
+            <a:ext cx="2560320" cy="987552"/>
           </a:xfrm>
           <a:prstGeom prst="rect">
             <a:avLst/>
@@ -9981,7 +9981,7 @@
         <p:spPr>
           <a:xfrm>
             <a:off x="685800" y="5001767"/>
-            <a:ext cx="2194560" cy="411480"/>
+            <a:ext cx="2377440" cy="411480"/>
           </a:xfrm>
           <a:prstGeom prst="rect">
             <a:avLst/>
@@ -9996,13 +9996,13 @@
           <a:p>
             <a:pPr algn="ctr"/>
             <a:r>
-              <a:rPr sz="1500" b="1">
+              <a:rPr sz="1400" b="1">
                 <a:solidFill>
                   <a:srgbClr val="FFFFFF"/>
                 </a:solidFill>
                 <a:latin typeface="Calibri"/>
               </a:rPr>
-              <a:t>Document clearly</a:t>
+              <a:t>Document</a:t>
             </a:r>
           </a:p>
         </p:txBody>
@@ -10015,8 +10015,8 @@
         </p:nvSpPr>
         <p:spPr>
           <a:xfrm>
-            <a:off x="3200400" y="4983479"/>
-            <a:ext cx="8046720" cy="502920"/>
+            <a:off x="3383280" y="4983479"/>
+            <a:ext cx="7863840" cy="502920"/>
           </a:xfrm>
           <a:prstGeom prst="rect">
             <a:avLst/>
@@ -10037,7 +10037,7 @@
                 </a:solidFill>
                 <a:latin typeface="Calibri"/>
               </a:rPr>
-              <a:t>Produce readable summaries so non-specialists can join the readiness conversation.</a:t>
+              <a:t>Keep a clear record of pipeline design so control intent stays visible.</a:t>
             </a:r>
           </a:p>
         </p:txBody>
@@ -10219,7 +10219,7 @@
                 </a:solidFill>
                 <a:latin typeface="Calibri"/>
               </a:rPr>
-              <a:t>The risk we need to surface</a:t>
+              <a:t>Where we identify and place controls</a:t>
             </a:r>
           </a:p>
         </p:txBody>
@@ -10254,7 +10254,7 @@
                 </a:solidFill>
                 <a:latin typeface="Calibri"/>
               </a:rPr>
-              <a:t>Common delivery debt — explained without jargon</a:t>
+              <a:t>Control areas that make delivery safer by design</a:t>
             </a:r>
           </a:p>
         </p:txBody>
@@ -10289,7 +10289,7 @@
                 </a:solidFill>
                 <a:latin typeface="Calibri"/>
               </a:rPr>
-              <a:t>Gitlab Compliance  ·  Stakeholder briefing</a:t>
+              <a:t>Gitlab Compliance  ·  Secure by design</a:t>
             </a:r>
           </a:p>
         </p:txBody>
@@ -10402,7 +10402,7 @@
                 </a:solidFill>
                 <a:latin typeface="Calibri"/>
               </a:rPr>
-              <a:t>Untrusted building blocks</a:t>
+              <a:t>Trusted components</a:t>
             </a:r>
           </a:p>
         </p:txBody>
@@ -10437,7 +10437,7 @@
                 </a:solidFill>
                 <a:latin typeface="Calibri"/>
               </a:rPr>
-              <a:t>Projects using components that can change without notice.</a:t>
+              <a:t>Control: only known, pinned building blocks.</a:t>
             </a:r>
           </a:p>
         </p:txBody>
@@ -10515,7 +10515,7 @@
                 </a:solidFill>
                 <a:latin typeface="Calibri"/>
               </a:rPr>
-              <a:t>Out-of-date dependencies</a:t>
+              <a:t>Dependency freshness</a:t>
             </a:r>
           </a:p>
         </p:txBody>
@@ -10550,7 +10550,7 @@
                 </a:solidFill>
                 <a:latin typeface="Calibri"/>
               </a:rPr>
-              <a:t>Critical parts lagging behind agreed freshness windows.</a:t>
+              <a:t>Control: stay within agreed update windows.</a:t>
             </a:r>
           </a:p>
         </p:txBody>
@@ -10628,7 +10628,7 @@
                 </a:solidFill>
                 <a:latin typeface="Calibri"/>
               </a:rPr>
-              <a:t>Weak release guards</a:t>
+              <a:t>Release guards</a:t>
             </a:r>
           </a:p>
         </p:txBody>
@@ -10663,7 +10663,7 @@
                 </a:solidFill>
                 <a:latin typeface="Calibri"/>
               </a:rPr>
-              <a:t>Steps that can run when they should not.</a:t>
+              <a:t>Control: steps run only when intended.</a:t>
             </a:r>
           </a:p>
         </p:txBody>
@@ -10741,7 +10741,7 @@
                 </a:solidFill>
                 <a:latin typeface="Calibri"/>
               </a:rPr>
-              <a:t>Bypassed standards</a:t>
+              <a:t>Shared delivery patterns</a:t>
             </a:r>
           </a:p>
         </p:txBody>
@@ -10776,7 +10776,7 @@
                 </a:solidFill>
                 <a:latin typeface="Calibri"/>
               </a:rPr>
-              <a:t>Teams skipping the shared delivery patterns.</a:t>
+              <a:t>Control: standard templates are applied consistently.</a:t>
             </a:r>
           </a:p>
         </p:txBody>
@@ -10854,7 +10854,7 @@
                 </a:solidFill>
                 <a:latin typeface="Calibri"/>
               </a:rPr>
-              <a:t>Poor visibility</a:t>
+              <a:t>Pipeline visibility</a:t>
             </a:r>
           </a:p>
         </p:txBody>
@@ -10889,7 +10889,7 @@
                 </a:solidFill>
                 <a:latin typeface="Calibri"/>
               </a:rPr>
-              <a:t>No clear picture of how a pipeline works today.</a:t>
+              <a:t>Control: current design is documented and reviewable.</a:t>
             </a:r>
           </a:p>
         </p:txBody>
@@ -10967,7 +10967,7 @@
                 </a:solidFill>
                 <a:latin typeface="Calibri"/>
               </a:rPr>
-              <a:t>Policy only on paper</a:t>
+              <a:t>Automated assurance</a:t>
             </a:r>
           </a:p>
         </p:txBody>
@@ -11002,7 +11002,7 @@
                 </a:solidFill>
                 <a:latin typeface="Calibri"/>
               </a:rPr>
-              <a:t>Rules exist in guidance, but are not checked automatically.</a:t>
+              <a:t>Control: expectations are checked continuously, not only on paper.</a:t>
             </a:r>
           </a:p>
         </p:txBody>
@@ -11184,7 +11184,7 @@
                 </a:solidFill>
                 <a:latin typeface="Calibri"/>
               </a:rPr>
-              <a:t>The journey</a:t>
+              <a:t>From gap to control</a:t>
             </a:r>
           </a:p>
         </p:txBody>
@@ -11219,7 +11219,7 @@
                 </a:solidFill>
                 <a:latin typeface="Calibri"/>
               </a:rPr>
-              <a:t>From unknown risk to confident, ongoing control</a:t>
+              <a:t>A practical path to secure-by-design delivery</a:t>
             </a:r>
           </a:p>
         </p:txBody>
@@ -11254,7 +11254,7 @@
                 </a:solidFill>
                 <a:latin typeface="Calibri"/>
               </a:rPr>
-              <a:t>Gitlab Compliance  ·  Stakeholder briefing</a:t>
+              <a:t>Gitlab Compliance  ·  Secure by design</a:t>
             </a:r>
           </a:p>
         </p:txBody>
@@ -11445,7 +11445,7 @@
                 </a:solidFill>
                 <a:latin typeface="Calibri"/>
               </a:rPr>
-              <a:t>Discover</a:t>
+              <a:t>Identify</a:t>
             </a:r>
           </a:p>
         </p:txBody>
@@ -11480,7 +11480,7 @@
                 </a:solidFill>
                 <a:latin typeface="Calibri"/>
               </a:rPr>
-              <a:t>Scan the migration cohort and produce a clear risk list.</a:t>
+              <a:t>Baseline where intended controls are missing or incomplete.</a:t>
             </a:r>
           </a:p>
         </p:txBody>
@@ -11671,7 +11671,7 @@
                 </a:solidFill>
                 <a:latin typeface="Calibri"/>
               </a:rPr>
-              <a:t>Focus first on the highest-impact projects and gaps.</a:t>
+              <a:t>Focus first on highest-impact control gaps for Dedicated and Nexus.</a:t>
             </a:r>
           </a:p>
         </p:txBody>
@@ -11827,7 +11827,7 @@
                 </a:solidFill>
                 <a:latin typeface="Calibri"/>
               </a:rPr>
-              <a:t>Remediate</a:t>
+              <a:t>Place controls</a:t>
             </a:r>
           </a:p>
         </p:txBody>
@@ -11862,7 +11862,7 @@
                 </a:solidFill>
                 <a:latin typeface="Calibri"/>
               </a:rPr>
-              <a:t>Fix supply-chain and standards issues with reviewable changes.</a:t>
+              <a:t>Apply readable policies and remediations with reviewable change.</a:t>
             </a:r>
           </a:p>
         </p:txBody>
@@ -12018,7 +12018,7 @@
                 </a:solidFill>
                 <a:latin typeface="Calibri"/>
               </a:rPr>
-              <a:t>Explain</a:t>
+              <a:t>Measure</a:t>
             </a:r>
           </a:p>
         </p:txBody>
@@ -12053,7 +12053,7 @@
                 </a:solidFill>
                 <a:latin typeface="Calibri"/>
               </a:rPr>
-              <a:t>Share readable reports and pipeline summaries with stakeholders.</a:t>
+              <a:t>Track coverage and findings with shared reports and summaries.</a:t>
             </a:r>
           </a:p>
         </p:txBody>
@@ -12209,7 +12209,7 @@
                 </a:solidFill>
                 <a:latin typeface="Calibri"/>
               </a:rPr>
-              <a:t>Maintain</a:t>
+              <a:t>Sustain</a:t>
             </a:r>
           </a:p>
         </p:txBody>
@@ -12244,7 +12244,7 @@
                 </a:solidFill>
                 <a:latin typeface="Calibri"/>
               </a:rPr>
-              <a:t>Keep the same plain-language standards in force after go-live.</a:t>
+              <a:t>Keep detection in place so secure-by-design behaviour continues after go-live.</a:t>
             </a:r>
           </a:p>
         </p:txBody>
@@ -12426,7 +12426,7 @@
                 </a:solidFill>
                 <a:latin typeface="Calibri"/>
               </a:rPr>
-              <a:t>Standards people can understand</a:t>
+              <a:t>Controls written so people understand them</a:t>
             </a:r>
           </a:p>
         </p:txBody>
@@ -12461,7 +12461,7 @@
                 </a:solidFill>
                 <a:latin typeface="Calibri"/>
               </a:rPr>
-              <a:t>Easy-to-read policies keep the rules alive after migration</a:t>
+              <a:t>Readable policies make secure by design sustainable</a:t>
             </a:r>
           </a:p>
         </p:txBody>
@@ -12496,7 +12496,7 @@
                 </a:solidFill>
                 <a:latin typeface="Calibri"/>
               </a:rPr>
-              <a:t>Gitlab Compliance  ·  Stakeholder briefing</a:t>
+              <a:t>Gitlab Compliance  ·  Secure by design</a:t>
             </a:r>
           </a:p>
         </p:txBody>
@@ -12566,7 +12566,7 @@
                 </a:solidFill>
                 <a:latin typeface="Calibri"/>
               </a:rPr>
-              <a:t>Migration finds the debt once. Clear policies make sure the same expectations stay true every day after.</a:t>
+              <a:t>A control only works if people can understand it, apply it, and see when it is missing.</a:t>
             </a:r>
           </a:p>
         </p:txBody>
@@ -12644,7 +12644,7 @@
                 </a:solidFill>
                 <a:latin typeface="Calibri"/>
               </a:rPr>
-              <a:t>Business benefits</a:t>
+              <a:t>Why readable controls matter</a:t>
             </a:r>
           </a:p>
         </p:txBody>
@@ -12683,7 +12683,7 @@
                 </a:solidFill>
                 <a:latin typeface="Calibri"/>
               </a:rPr>
-              <a:t>Security and delivery share one understandable contract</a:t>
+              <a:t>Security and delivery share one understandable control definition</a:t>
             </a:r>
           </a:p>
           <a:p>
@@ -12699,7 +12699,7 @@
                 </a:solidFill>
                 <a:latin typeface="Calibri"/>
               </a:rPr>
-              <a:t>New Nexus or Dedicated rules can be written plainly</a:t>
+              <a:t>New Nexus or Dedicated expectations can be expressed clearly</a:t>
             </a:r>
           </a:p>
           <a:p>
@@ -12715,7 +12715,7 @@
                 </a:solidFill>
                 <a:latin typeface="Calibri"/>
               </a:rPr>
-              <a:t>Ownership is clear — standards are not buried in tribal knowledge</a:t>
+              <a:t>Detection findings are explainable without specialist decoding</a:t>
             </a:r>
           </a:p>
           <a:p>
@@ -12731,7 +12731,7 @@
                 </a:solidFill>
                 <a:latin typeface="Calibri"/>
               </a:rPr>
-              <a:t>Findings are explainable in programme forums</a:t>
+              <a:t>Control ownership is visible and versioned</a:t>
             </a:r>
           </a:p>
           <a:p>
@@ -12747,7 +12747,7 @@
                 </a:solidFill>
                 <a:latin typeface="Calibri"/>
               </a:rPr>
-              <a:t>Standards survive team and supplier change</a:t>
+              <a:t>Standards remain usable as teams and suppliers change</a:t>
             </a:r>
           </a:p>
         </p:txBody>
@@ -12825,7 +12825,7 @@
                 </a:solidFill>
                 <a:latin typeface="Calibri"/>
               </a:rPr>
-              <a:t>Example of a readable rule</a:t>
+              <a:t>Example of a clear control</a:t>
             </a:r>
           </a:p>
         </p:txBody>
@@ -12860,7 +12860,7 @@
                 </a:solidFill>
                 <a:latin typeface="Calibri"/>
               </a:rPr>
-              <a:t>“If a job uses a software image, it must not use an open-ended ‘latest’ version.”</a:t>
+              <a:t>“Software images used in delivery must not rely on an open-ended ‘latest’ version.”</a:t>
             </a:r>
             <a:br/>
             <a:br/>
@@ -12871,7 +12871,7 @@
                 </a:solidFill>
                 <a:latin typeface="Calibri"/>
               </a:rPr>
-              <a:t>That idea becomes a short scenario both technical and non-technical colleagues can follow — and the check confirms it is true before approval.</a:t>
+              <a:t>That control is written in plain language, checked automatically, and creates a measurable signal when it is not yet in place.</a:t>
             </a:r>
           </a:p>
         </p:txBody>

</xml_diff>

<commit_message>
docs: refine briefing for unintentional non-conformance
Clarify secure-by-design messaging: measure controls, detect
non-conforming code as usually unintentional drift, and define what
good looks like as identifying and placing controls.

Co-authored-by: Charlie Smith <casdev2020@users.noreply.github.com>
</commit_message>
<xml_diff>
--- a/docs/presentations/gitlab-compliance-stakeholder-briefing.pptx
+++ b/docs/presentations/gitlab-compliance-stakeholder-briefing.pptx
@@ -3328,7 +3328,7 @@
                 </a:solidFill>
                 <a:latin typeface="Calibri"/>
               </a:rPr>
-              <a:t>A way to measure, detect, and place controls in delivery pipelines — so Dedicated migration and Nexus expectations are guided by evidence, not assumption.</a:t>
+              <a:t>Measure control coverage, detect non-conforming configuration, and place controls in delivery pipelines — so Dedicated migration and Nexus expectations are guided by evidence.</a:t>
             </a:r>
           </a:p>
         </p:txBody>
@@ -3367,7 +3367,7 @@
                 </a:solidFill>
                 <a:latin typeface="Calibri"/>
               </a:rPr>
-              <a:t>Measurement · Detection · Data-driven behaviour</a:t>
+              <a:t>Measurement · Detection of non-conforming code · Place controls</a:t>
             </a:r>
           </a:p>
           <a:p>
@@ -3383,7 +3383,7 @@
                 </a:solidFill>
                 <a:latin typeface="Calibri"/>
               </a:rPr>
-              <a:t>Readable controls that stay in place after go-live</a:t>
+              <a:t>Non-conformance is usually unintentional drift — not deliberate rule-breaking</a:t>
             </a:r>
           </a:p>
         </p:txBody>
@@ -4294,7 +4294,7 @@
                 </a:solidFill>
                 <a:latin typeface="Calibri"/>
               </a:rPr>
-              <a:t>Gaps detected early enough to place controls calmly</a:t>
+              <a:t>Non-conforming code detected early enough to place controls calmly</a:t>
             </a:r>
           </a:p>
         </p:txBody>
@@ -4823,7 +4823,7 @@
                 </a:solidFill>
                 <a:latin typeface="Calibri"/>
               </a:rPr>
-              <a:t>Controls identified, placed, and continuously detectable</a:t>
+              <a:t>Identifying and placing controls — then measuring continuously</a:t>
             </a:r>
           </a:p>
         </p:txBody>
@@ -5197,7 +5197,7 @@
                 </a:solidFill>
                 <a:latin typeface="Calibri"/>
               </a:rPr>
-              <a:t>Detection active</a:t>
+              <a:t>Non-conformance detected</a:t>
             </a:r>
           </a:p>
         </p:txBody>
@@ -5232,7 +5232,7 @@
                 </a:solidFill>
                 <a:latin typeface="Calibri"/>
               </a:rPr>
-              <a:t>Gaps are spotted automatically before approval.</a:t>
+              <a:t>Non-conforming code is spotted automatically before approval.</a:t>
             </a:r>
           </a:p>
         </p:txBody>
@@ -5458,7 +5458,7 @@
                 </a:solidFill>
                 <a:latin typeface="Calibri"/>
               </a:rPr>
-              <a:t>Priorities follow measured gap severity, not anecdote.</a:t>
+              <a:t>Priorities follow measured non-conformance severity, not anecdote.</a:t>
             </a:r>
           </a:p>
         </p:txBody>
@@ -5749,7 +5749,7 @@
                 </a:solidFill>
                 <a:latin typeface="Calibri"/>
               </a:rPr>
-              <a:t>1.  Define the controls that matter for Dedicated readiness and Nexus assurance</a:t>
+              <a:t>1.  Identify the controls that matter for Dedicated readiness and Nexus assurance</a:t>
             </a:r>
           </a:p>
           <a:p>
@@ -5781,7 +5781,7 @@
                 </a:solidFill>
                 <a:latin typeface="Calibri"/>
               </a:rPr>
-              <a:t>3.  Detect remaining gaps early and place controls with reviewable change</a:t>
+              <a:t>3.  Detect unintentional non-conforming code early and place controls with reviewable change</a:t>
             </a:r>
           </a:p>
           <a:p>
@@ -5848,7 +5848,7 @@
                 </a:solidFill>
                 <a:latin typeface="Calibri"/>
               </a:rPr>
-              <a:t>What good looks like: controls identified, placed, measured, and continuously detectable.</a:t>
+              <a:t>What good looks like: controls identified and placed — with continuous detection of non-conformance.</a:t>
             </a:r>
           </a:p>
         </p:txBody>
@@ -6254,7 +6254,7 @@
                 </a:solidFill>
                 <a:latin typeface="Calibri"/>
               </a:rPr>
-              <a:t>6.  What good looks like</a:t>
+              <a:t>6.  What good looks like — identify and place controls</a:t>
             </a:r>
           </a:p>
         </p:txBody>
@@ -6471,7 +6471,7 @@
                 </a:solidFill>
                 <a:latin typeface="Calibri"/>
               </a:rPr>
-              <a:t>Without measurement, control gaps stay invisible until late</a:t>
+              <a:t>Without measurement, unintentional non-conformance stays invisible until late</a:t>
             </a:r>
           </a:p>
         </p:txBody>
@@ -6853,7 +6853,7 @@
                 </a:solidFill>
                 <a:latin typeface="Calibri"/>
               </a:rPr>
-              <a:t>Gaps appear late — often near go-live — when change is expensive.</a:t>
+              <a:t>Non-conforming configuration often appears late — near go-live — when change is expensive.</a:t>
             </a:r>
           </a:p>
         </p:txBody>
@@ -7009,7 +7009,7 @@
                 </a:solidFill>
                 <a:latin typeface="Calibri"/>
               </a:rPr>
-              <a:t>Expectations exist in guidance, but are not consistently applied in pipelines.</a:t>
+              <a:t>Expectations exist in guidance, but drift into non-conformance is usually unintentional — not deliberate.</a:t>
             </a:r>
           </a:p>
         </p:txBody>
@@ -7628,7 +7628,7 @@
                 </a:solidFill>
                 <a:latin typeface="Calibri"/>
               </a:rPr>
-              <a:t>Unknown gaps become schedule and service risk</a:t>
+              <a:t>Undetected non-conformance becomes schedule and service risk</a:t>
             </a:r>
           </a:p>
           <a:p>
@@ -7660,7 +7660,7 @@
                 </a:solidFill>
                 <a:latin typeface="Calibri"/>
               </a:rPr>
-              <a:t>Secure by design means controls are in place before the move</a:t>
+              <a:t>Secure by design means controls are identified and placed before the move</a:t>
             </a:r>
           </a:p>
         </p:txBody>
@@ -8085,7 +8085,7 @@
                 </a:solidFill>
                 <a:latin typeface="Calibri"/>
               </a:rPr>
-              <a:t>A measurement and detection layer for delivery controls</a:t>
+              <a:t>Measurement and detection of non-conforming code — then place controls</a:t>
             </a:r>
           </a:p>
         </p:txBody>
@@ -8190,7 +8190,7 @@
                 </a:solidFill>
                 <a:latin typeface="Calibri"/>
               </a:rPr>
-              <a:t>It turns agreed security expectations into detectable signals — so teams can place controls early and improve based on data.</a:t>
+              <a:t>It turns agreed security expectations into measurable signals — detecting unintentional non-conforming configuration early so controls can be placed with confidence.</a:t>
             </a:r>
           </a:p>
         </p:txBody>
@@ -8467,7 +8467,7 @@
                 </a:solidFill>
                 <a:latin typeface="Calibri"/>
               </a:rPr>
-              <a:t>Detect</a:t>
+              <a:t>Detect non-conformance</a:t>
             </a:r>
           </a:p>
         </p:txBody>
@@ -8502,7 +8502,7 @@
                 </a:solidFill>
                 <a:latin typeface="Calibri"/>
               </a:rPr>
-              <a:t>Surface gaps before approval — while change is still low-cost.</a:t>
+              <a:t>Find non-conforming code and configuration before approval — usually drift, not intent.</a:t>
             </a:r>
           </a:p>
         </p:txBody>
@@ -8814,7 +8814,7 @@
                 </a:solidFill>
                 <a:latin typeface="Calibri"/>
               </a:rPr>
-              <a:t>Readable policies define the control; checks confirm it is applied.</a:t>
+              <a:t>Readable policies define the control; checks confirm it is in place.</a:t>
             </a:r>
           </a:p>
         </p:txBody>
@@ -9569,7 +9569,7 @@
                 </a:solidFill>
                 <a:latin typeface="Calibri"/>
               </a:rPr>
-              <a:t>Detect whether each project meets the intended control standard.</a:t>
+              <a:t>Detect non-conforming configuration against the intended control standard.</a:t>
             </a:r>
           </a:p>
         </p:txBody>
@@ -9725,7 +9725,7 @@
                 </a:solidFill>
                 <a:latin typeface="Calibri"/>
               </a:rPr>
-              <a:t>Measure coverage across the migration cohort with a shared risk view.</a:t>
+              <a:t>Measure coverage across the migration cohort with a shared evidence view.</a:t>
             </a:r>
           </a:p>
         </p:txBody>
@@ -11184,7 +11184,7 @@
                 </a:solidFill>
                 <a:latin typeface="Calibri"/>
               </a:rPr>
-              <a:t>From gap to control</a:t>
+              <a:t>From non-conformance to control</a:t>
             </a:r>
           </a:p>
         </p:txBody>
@@ -11671,7 +11671,7 @@
                 </a:solidFill>
                 <a:latin typeface="Calibri"/>
               </a:rPr>
-              <a:t>Focus first on highest-impact control gaps for Dedicated and Nexus.</a:t>
+              <a:t>Focus first on highest-impact non-conformance for Dedicated and Nexus.</a:t>
             </a:r>
           </a:p>
         </p:txBody>
@@ -12053,7 +12053,7 @@
                 </a:solidFill>
                 <a:latin typeface="Calibri"/>
               </a:rPr>
-              <a:t>Track coverage and findings with shared reports and summaries.</a:t>
+              <a:t>Track coverage and non-conformance findings with shared reports.</a:t>
             </a:r>
           </a:p>
         </p:txBody>
@@ -12244,7 +12244,7 @@
                 </a:solidFill>
                 <a:latin typeface="Calibri"/>
               </a:rPr>
-              <a:t>Keep detection in place so secure-by-design behaviour continues after go-live.</a:t>
+              <a:t>Keep detection in place so unintentional drift is caught after go-live.</a:t>
             </a:r>
           </a:p>
         </p:txBody>
@@ -12566,7 +12566,7 @@
                 </a:solidFill>
                 <a:latin typeface="Calibri"/>
               </a:rPr>
-              <a:t>A control only works if people can understand it, apply it, and see when it is missing.</a:t>
+              <a:t>A control only works if people can understand it, place it, and detect when configuration drifts.</a:t>
             </a:r>
           </a:p>
         </p:txBody>
@@ -12715,7 +12715,7 @@
                 </a:solidFill>
                 <a:latin typeface="Calibri"/>
               </a:rPr>
-              <a:t>Detection findings are explainable without specialist decoding</a:t>
+              <a:t>Non-conformance findings are explainable without specialist decoding</a:t>
             </a:r>
           </a:p>
           <a:p>
@@ -12871,7 +12871,7 @@
                 </a:solidFill>
                 <a:latin typeface="Calibri"/>
               </a:rPr>
-              <a:t>That control is written in plain language, checked automatically, and creates a measurable signal when it is not yet in place.</a:t>
+              <a:t>That control is written in plain language, checked automatically, and creates a measurable signal when non-conforming configuration appears — usually by accident, not intent.</a:t>
             </a:r>
           </a:p>
         </p:txBody>

</xml_diff>

<commit_message>
docs: add speaker notes to stakeholder briefing slides
Each of the 12 slides now includes presenter notes reinforcing
secure-by-design framing and unintentional non-conformance messaging.

Co-authored-by: Charlie Smith <casdev2020@users.noreply.github.com>
</commit_message>
<xml_diff>
--- a/docs/presentations/gitlab-compliance-stakeholder-briefing.pptx
+++ b/docs/presentations/gitlab-compliance-stakeholder-briefing.pptx
@@ -6,17 +6,17 @@
   </p:sldMasterIdLst>
   <p:sldIdLst>
     <p:sldId id="256" r:id="rId7"/>
-    <p:sldId id="257" r:id="rId8"/>
-    <p:sldId id="258" r:id="rId9"/>
-    <p:sldId id="259" r:id="rId10"/>
-    <p:sldId id="260" r:id="rId11"/>
-    <p:sldId id="261" r:id="rId12"/>
-    <p:sldId id="262" r:id="rId13"/>
-    <p:sldId id="263" r:id="rId14"/>
-    <p:sldId id="264" r:id="rId15"/>
-    <p:sldId id="265" r:id="rId16"/>
-    <p:sldId id="266" r:id="rId17"/>
-    <p:sldId id="267" r:id="rId18"/>
+    <p:sldId id="257" r:id="rId9"/>
+    <p:sldId id="258" r:id="rId10"/>
+    <p:sldId id="259" r:id="rId11"/>
+    <p:sldId id="260" r:id="rId12"/>
+    <p:sldId id="261" r:id="rId13"/>
+    <p:sldId id="262" r:id="rId14"/>
+    <p:sldId id="263" r:id="rId15"/>
+    <p:sldId id="264" r:id="rId16"/>
+    <p:sldId id="265" r:id="rId17"/>
+    <p:sldId id="266" r:id="rId18"/>
+    <p:sldId id="267" r:id="rId19"/>
   </p:sldIdLst>
   <p:sldSz cx="12191695" cy="6858000" type="screen4x3"/>
   <p:notesSz cx="6858000" cy="9144000"/>
@@ -116,6 +116,1712 @@
     </a:lvl9pPr>
   </p:defaultTextStyle>
 </p:presentation>
+</file>
+
+<file path=ppt/notesMasters/notesMaster1.xml><?xml version="1.0" encoding="utf-8"?>
+<p:notesMaster xmlns:a="http://schemas.openxmlformats.org/drawingml/2006/main" xmlns:p="http://schemas.openxmlformats.org/presentationml/2006/main" xmlns:r="http://schemas.openxmlformats.org/officeDocument/2006/relationships">
+  <p:cSld>
+    <p:bg>
+      <p:bgRef idx="1001">
+        <a:schemeClr val="bg1"/>
+      </p:bgRef>
+    </p:bg>
+    <p:spTree>
+      <p:nvGrpSpPr>
+        <p:cNvPr id="1" name=""/>
+        <p:cNvGrpSpPr/>
+        <p:nvPr/>
+      </p:nvGrpSpPr>
+      <p:grpSpPr>
+        <a:xfrm>
+          <a:off x="0" y="0"/>
+          <a:ext cx="0" cy="0"/>
+          <a:chOff x="0" y="0"/>
+          <a:chExt cx="0" cy="0"/>
+        </a:xfrm>
+      </p:grpSpPr>
+      <p:sp>
+        <p:nvSpPr>
+          <p:cNvPr id="2" name="Header Placeholder 1"/>
+          <p:cNvSpPr>
+            <a:spLocks noGrp="1"/>
+          </p:cNvSpPr>
+          <p:nvPr>
+            <p:ph type="hdr" sz="quarter"/>
+          </p:nvPr>
+        </p:nvSpPr>
+        <p:spPr>
+          <a:xfrm>
+            <a:off x="0" y="0"/>
+            <a:ext cx="2971800" cy="457200"/>
+          </a:xfrm>
+          <a:prstGeom prst="rect">
+            <a:avLst/>
+          </a:prstGeom>
+        </p:spPr>
+        <p:txBody>
+          <a:bodyPr vert="horz" lIns="91440" tIns="45720" rIns="91440" bIns="45720" rtlCol="0"/>
+          <a:lstStyle>
+            <a:lvl1pPr algn="l">
+              <a:defRPr sz="1200"/>
+            </a:lvl1pPr>
+          </a:lstStyle>
+          <a:p>
+            <a:endParaRPr lang="en-US"/>
+          </a:p>
+        </p:txBody>
+      </p:sp>
+      <p:sp>
+        <p:nvSpPr>
+          <p:cNvPr id="3" name="Date Placeholder 2"/>
+          <p:cNvSpPr>
+            <a:spLocks noGrp="1"/>
+          </p:cNvSpPr>
+          <p:nvPr>
+            <p:ph type="dt" idx="1"/>
+          </p:nvPr>
+        </p:nvSpPr>
+        <p:spPr>
+          <a:xfrm>
+            <a:off x="3884613" y="0"/>
+            <a:ext cx="2971800" cy="457200"/>
+          </a:xfrm>
+          <a:prstGeom prst="rect">
+            <a:avLst/>
+          </a:prstGeom>
+        </p:spPr>
+        <p:txBody>
+          <a:bodyPr vert="horz" lIns="91440" tIns="45720" rIns="91440" bIns="45720" rtlCol="0"/>
+          <a:lstStyle>
+            <a:lvl1pPr algn="r">
+              <a:defRPr sz="1200"/>
+            </a:lvl1pPr>
+          </a:lstStyle>
+          <a:p>
+            <a:fld id="{0F89C1C7-3DCD-1040-A9CF-14679D8B5DDD}" type="datetimeFigureOut">
+              <a:rPr lang="en-US" smtClean="0"/>
+              <a:t>10/17/16</a:t>
+            </a:fld>
+            <a:endParaRPr lang="en-US"/>
+          </a:p>
+        </p:txBody>
+      </p:sp>
+      <p:sp>
+        <p:nvSpPr>
+          <p:cNvPr id="4" name="Slide Image Placeholder 3"/>
+          <p:cNvSpPr>
+            <a:spLocks noGrp="1" noRot="1" noChangeAspect="1"/>
+          </p:cNvSpPr>
+          <p:nvPr>
+            <p:ph type="sldImg" idx="2"/>
+          </p:nvPr>
+        </p:nvSpPr>
+        <p:spPr>
+          <a:xfrm>
+            <a:off x="1143000" y="685800"/>
+            <a:ext cx="4572000" cy="3429000"/>
+          </a:xfrm>
+          <a:prstGeom prst="rect">
+            <a:avLst/>
+          </a:prstGeom>
+          <a:noFill/>
+          <a:ln w="12700">
+            <a:solidFill>
+              <a:prstClr val="black"/>
+            </a:solidFill>
+          </a:ln>
+        </p:spPr>
+        <p:txBody>
+          <a:bodyPr vert="horz" lIns="91440" tIns="45720" rIns="91440" bIns="45720" rtlCol="0" anchor="ctr"/>
+          <a:lstStyle/>
+          <a:p>
+            <a:endParaRPr lang="en-US"/>
+          </a:p>
+        </p:txBody>
+      </p:sp>
+      <p:sp>
+        <p:nvSpPr>
+          <p:cNvPr id="5" name="Notes Placeholder 4"/>
+          <p:cNvSpPr>
+            <a:spLocks noGrp="1"/>
+          </p:cNvSpPr>
+          <p:nvPr>
+            <p:ph type="body" sz="quarter" idx="3"/>
+          </p:nvPr>
+        </p:nvSpPr>
+        <p:spPr>
+          <a:xfrm>
+            <a:off x="685800" y="4343400"/>
+            <a:ext cx="5486400" cy="4114800"/>
+          </a:xfrm>
+          <a:prstGeom prst="rect">
+            <a:avLst/>
+          </a:prstGeom>
+        </p:spPr>
+        <p:txBody>
+          <a:bodyPr vert="horz" lIns="91440" tIns="45720" rIns="91440" bIns="45720" rtlCol="0"/>
+          <a:lstStyle/>
+          <a:p>
+            <a:pPr lvl="0"/>
+            <a:r>
+              <a:rPr lang="en-US" smtClean="0"/>
+              <a:t>Click to edit Master text styles</a:t>
+            </a:r>
+          </a:p>
+          <a:p>
+            <a:pPr lvl="1"/>
+            <a:r>
+              <a:rPr lang="en-US" smtClean="0"/>
+              <a:t>Second level</a:t>
+            </a:r>
+          </a:p>
+          <a:p>
+            <a:pPr lvl="2"/>
+            <a:r>
+              <a:rPr lang="en-US" smtClean="0"/>
+              <a:t>Third level</a:t>
+            </a:r>
+          </a:p>
+          <a:p>
+            <a:pPr lvl="3"/>
+            <a:r>
+              <a:rPr lang="en-US" smtClean="0"/>
+              <a:t>Fourth level</a:t>
+            </a:r>
+          </a:p>
+          <a:p>
+            <a:pPr lvl="4"/>
+            <a:r>
+              <a:rPr lang="en-US" smtClean="0"/>
+              <a:t>Fifth level</a:t>
+            </a:r>
+            <a:endParaRPr lang="en-US"/>
+          </a:p>
+        </p:txBody>
+      </p:sp>
+      <p:sp>
+        <p:nvSpPr>
+          <p:cNvPr id="6" name="Footer Placeholder 5"/>
+          <p:cNvSpPr>
+            <a:spLocks noGrp="1"/>
+          </p:cNvSpPr>
+          <p:nvPr>
+            <p:ph type="ftr" sz="quarter" idx="4"/>
+          </p:nvPr>
+        </p:nvSpPr>
+        <p:spPr>
+          <a:xfrm>
+            <a:off x="0" y="8685213"/>
+            <a:ext cx="2971800" cy="457200"/>
+          </a:xfrm>
+          <a:prstGeom prst="rect">
+            <a:avLst/>
+          </a:prstGeom>
+        </p:spPr>
+        <p:txBody>
+          <a:bodyPr vert="horz" lIns="91440" tIns="45720" rIns="91440" bIns="45720" rtlCol="0" anchor="b"/>
+          <a:lstStyle>
+            <a:lvl1pPr algn="l">
+              <a:defRPr sz="1200"/>
+            </a:lvl1pPr>
+          </a:lstStyle>
+          <a:p>
+            <a:endParaRPr lang="en-US"/>
+          </a:p>
+        </p:txBody>
+      </p:sp>
+      <p:sp>
+        <p:nvSpPr>
+          <p:cNvPr id="7" name="Slide Number Placeholder 6"/>
+          <p:cNvSpPr>
+            <a:spLocks noGrp="1"/>
+          </p:cNvSpPr>
+          <p:nvPr>
+            <p:ph type="sldNum" sz="quarter" idx="5"/>
+          </p:nvPr>
+        </p:nvSpPr>
+        <p:spPr>
+          <a:xfrm>
+            <a:off x="3884613" y="8685213"/>
+            <a:ext cx="2971800" cy="457200"/>
+          </a:xfrm>
+          <a:prstGeom prst="rect">
+            <a:avLst/>
+          </a:prstGeom>
+        </p:spPr>
+        <p:txBody>
+          <a:bodyPr vert="horz" lIns="91440" tIns="45720" rIns="91440" bIns="45720" rtlCol="0" anchor="b"/>
+          <a:lstStyle>
+            <a:lvl1pPr algn="r">
+              <a:defRPr sz="1200"/>
+            </a:lvl1pPr>
+          </a:lstStyle>
+          <a:p>
+            <a:fld id="{BB5E49A5-4136-284D-997B-48E1D791AD67}" type="slidenum">
+              <a:rPr lang="en-US" smtClean="0"/>
+              <a:t>‹#›</a:t>
+            </a:fld>
+            <a:endParaRPr lang="en-US"/>
+          </a:p>
+        </p:txBody>
+      </p:sp>
+    </p:spTree>
+    <p:extLst>
+      <p:ext uri="{BB962C8B-B14F-4D97-AF65-F5344CB8AC3E}">
+        <p14:creationId xmlns:p14="http://schemas.microsoft.com/office/powerpoint/2010/main" val="2623252185"/>
+      </p:ext>
+    </p:extLst>
+  </p:cSld>
+  <p:clrMap bg1="lt1" tx1="dk1" bg2="lt2" tx2="dk2" accent1="accent1" accent2="accent2" accent3="accent3" accent4="accent4" accent5="accent5" accent6="accent6" hlink="hlink" folHlink="folHlink"/>
+  <p:notesStyle>
+    <a:lvl1pPr marL="0" algn="l" defTabSz="457200" rtl="0" eaLnBrk="1" latinLnBrk="0" hangingPunct="1">
+      <a:defRPr sz="1200" kern="1200">
+        <a:solidFill>
+          <a:schemeClr val="tx1"/>
+        </a:solidFill>
+        <a:latin typeface="+mn-lt"/>
+        <a:ea typeface="+mn-ea"/>
+        <a:cs typeface="+mn-cs"/>
+      </a:defRPr>
+    </a:lvl1pPr>
+    <a:lvl2pPr marL="457200" algn="l" defTabSz="457200" rtl="0" eaLnBrk="1" latinLnBrk="0" hangingPunct="1">
+      <a:defRPr sz="1200" kern="1200">
+        <a:solidFill>
+          <a:schemeClr val="tx1"/>
+        </a:solidFill>
+        <a:latin typeface="+mn-lt"/>
+        <a:ea typeface="+mn-ea"/>
+        <a:cs typeface="+mn-cs"/>
+      </a:defRPr>
+    </a:lvl2pPr>
+    <a:lvl3pPr marL="914400" algn="l" defTabSz="457200" rtl="0" eaLnBrk="1" latinLnBrk="0" hangingPunct="1">
+      <a:defRPr sz="1200" kern="1200">
+        <a:solidFill>
+          <a:schemeClr val="tx1"/>
+        </a:solidFill>
+        <a:latin typeface="+mn-lt"/>
+        <a:ea typeface="+mn-ea"/>
+        <a:cs typeface="+mn-cs"/>
+      </a:defRPr>
+    </a:lvl3pPr>
+    <a:lvl4pPr marL="1371600" algn="l" defTabSz="457200" rtl="0" eaLnBrk="1" latinLnBrk="0" hangingPunct="1">
+      <a:defRPr sz="1200" kern="1200">
+        <a:solidFill>
+          <a:schemeClr val="tx1"/>
+        </a:solidFill>
+        <a:latin typeface="+mn-lt"/>
+        <a:ea typeface="+mn-ea"/>
+        <a:cs typeface="+mn-cs"/>
+      </a:defRPr>
+    </a:lvl4pPr>
+    <a:lvl5pPr marL="1828800" algn="l" defTabSz="457200" rtl="0" eaLnBrk="1" latinLnBrk="0" hangingPunct="1">
+      <a:defRPr sz="1200" kern="1200">
+        <a:solidFill>
+          <a:schemeClr val="tx1"/>
+        </a:solidFill>
+        <a:latin typeface="+mn-lt"/>
+        <a:ea typeface="+mn-ea"/>
+        <a:cs typeface="+mn-cs"/>
+      </a:defRPr>
+    </a:lvl5pPr>
+    <a:lvl6pPr marL="2286000" algn="l" defTabSz="457200" rtl="0" eaLnBrk="1" latinLnBrk="0" hangingPunct="1">
+      <a:defRPr sz="1200" kern="1200">
+        <a:solidFill>
+          <a:schemeClr val="tx1"/>
+        </a:solidFill>
+        <a:latin typeface="+mn-lt"/>
+        <a:ea typeface="+mn-ea"/>
+        <a:cs typeface="+mn-cs"/>
+      </a:defRPr>
+    </a:lvl6pPr>
+    <a:lvl7pPr marL="2743200" algn="l" defTabSz="457200" rtl="0" eaLnBrk="1" latinLnBrk="0" hangingPunct="1">
+      <a:defRPr sz="1200" kern="1200">
+        <a:solidFill>
+          <a:schemeClr val="tx1"/>
+        </a:solidFill>
+        <a:latin typeface="+mn-lt"/>
+        <a:ea typeface="+mn-ea"/>
+        <a:cs typeface="+mn-cs"/>
+      </a:defRPr>
+    </a:lvl7pPr>
+    <a:lvl8pPr marL="3200400" algn="l" defTabSz="457200" rtl="0" eaLnBrk="1" latinLnBrk="0" hangingPunct="1">
+      <a:defRPr sz="1200" kern="1200">
+        <a:solidFill>
+          <a:schemeClr val="tx1"/>
+        </a:solidFill>
+        <a:latin typeface="+mn-lt"/>
+        <a:ea typeface="+mn-ea"/>
+        <a:cs typeface="+mn-cs"/>
+      </a:defRPr>
+    </a:lvl8pPr>
+    <a:lvl9pPr marL="3657600" algn="l" defTabSz="457200" rtl="0" eaLnBrk="1" latinLnBrk="0" hangingPunct="1">
+      <a:defRPr sz="1200" kern="1200">
+        <a:solidFill>
+          <a:schemeClr val="tx1"/>
+        </a:solidFill>
+        <a:latin typeface="+mn-lt"/>
+        <a:ea typeface="+mn-ea"/>
+        <a:cs typeface="+mn-cs"/>
+      </a:defRPr>
+    </a:lvl9pPr>
+  </p:notesStyle>
+</p:notesMaster>
+</file>
+
+<file path=ppt/notesSlides/notesSlide1.xml><?xml version="1.0" encoding="utf-8"?>
+<p:notes xmlns:a="http://schemas.openxmlformats.org/drawingml/2006/main" xmlns:p="http://schemas.openxmlformats.org/presentationml/2006/main" xmlns:r="http://schemas.openxmlformats.org/officeDocument/2006/relationships">
+  <p:cSld>
+    <p:spTree>
+      <p:nvGrpSpPr>
+        <p:cNvPr id="1" name=""/>
+        <p:cNvGrpSpPr/>
+        <p:nvPr/>
+      </p:nvGrpSpPr>
+      <p:grpSpPr>
+        <a:xfrm>
+          <a:off x="0" y="0"/>
+          <a:ext cx="0" cy="0"/>
+          <a:chOff x="0" y="0"/>
+          <a:chExt cx="0" cy="0"/>
+        </a:xfrm>
+      </p:grpSpPr>
+      <p:sp>
+        <p:nvSpPr>
+          <p:cNvPr id="2" name="Slide Image Placeholder 1"/>
+          <p:cNvSpPr>
+            <a:spLocks noGrp="1"/>
+          </p:cNvSpPr>
+          <p:nvPr>
+            <p:ph type="sldImg" idx="2"/>
+          </p:nvPr>
+        </p:nvSpPr>
+        <p:spPr/>
+      </p:sp>
+      <p:sp>
+        <p:nvSpPr>
+          <p:cNvPr id="3" name="Notes Placeholder 2"/>
+          <p:cNvSpPr>
+            <a:spLocks noGrp="1"/>
+          </p:cNvSpPr>
+          <p:nvPr>
+            <p:ph type="body" idx="3" sz="quarter"/>
+          </p:nvPr>
+        </p:nvSpPr>
+        <p:spPr/>
+        <p:txBody>
+          <a:bodyPr wrap="square"/>
+          <a:lstStyle/>
+          <a:p>
+            <a:pPr>
+              <a:spcAft>
+                <a:spcPts val="800"/>
+              </a:spcAft>
+            </a:pPr>
+            <a:r>
+              <a:rPr sz="1200" b="0">
+                <a:solidFill>
+                  <a:srgbClr val="2A3B46"/>
+                </a:solidFill>
+                <a:latin typeface="Calibri"/>
+              </a:rPr>
+              <a:t>Open by framing secure by design — not a blame conversation.</a:t>
+            </a:r>
+          </a:p>
+          <a:p>
+            <a:pPr>
+              <a:spcAft>
+                <a:spcPts val="800"/>
+              </a:spcAft>
+            </a:pPr>
+            <a:r>
+              <a:rPr sz="1200" b="0">
+                <a:solidFill>
+                  <a:srgbClr val="2A3B46"/>
+                </a:solidFill>
+                <a:latin typeface="Calibri"/>
+              </a:rPr>
+              <a:t>Key message: Gitlab Compliance helps us measure control coverage, detect non-conforming configuration, and place controls so Dedicated and Nexus work is guided by evidence.</a:t>
+            </a:r>
+          </a:p>
+          <a:p>
+            <a:pPr>
+              <a:spcAft>
+                <a:spcPts val="800"/>
+              </a:spcAft>
+            </a:pPr>
+            <a:r>
+              <a:rPr sz="1200" b="0">
+                <a:solidFill>
+                  <a:srgbClr val="2A3B46"/>
+                </a:solidFill>
+                <a:latin typeface="Calibri"/>
+              </a:rPr>
+              <a:t>Emphasise that non-conformance is usually unintentional drift — people are not trying to break rules. We need visibility and detection so we can place the right controls early.</a:t>
+            </a:r>
+          </a:p>
+        </p:txBody>
+      </p:sp>
+      <p:sp>
+        <p:nvSpPr>
+          <p:cNvPr id="4" name="Slide Number Placeholder 3"/>
+          <p:cNvSpPr>
+            <a:spLocks noGrp="1"/>
+          </p:cNvSpPr>
+          <p:nvPr>
+            <p:ph type="sldNum" idx="5" sz="quarter"/>
+          </p:nvPr>
+        </p:nvSpPr>
+        <p:spPr/>
+      </p:sp>
+    </p:spTree>
+  </p:cSld>
+  <p:clrMapOvr>
+    <a:masterClrMapping/>
+  </p:clrMapOvr>
+</p:notes>
+</file>
+
+<file path=ppt/notesSlides/notesSlide10.xml><?xml version="1.0" encoding="utf-8"?>
+<p:notes xmlns:a="http://schemas.openxmlformats.org/drawingml/2006/main" xmlns:p="http://schemas.openxmlformats.org/presentationml/2006/main" xmlns:r="http://schemas.openxmlformats.org/officeDocument/2006/relationships">
+  <p:cSld>
+    <p:spTree>
+      <p:nvGrpSpPr>
+        <p:cNvPr id="1" name=""/>
+        <p:cNvGrpSpPr/>
+        <p:nvPr/>
+      </p:nvGrpSpPr>
+      <p:grpSpPr>
+        <a:xfrm>
+          <a:off x="0" y="0"/>
+          <a:ext cx="0" cy="0"/>
+          <a:chOff x="0" y="0"/>
+          <a:chExt cx="0" cy="0"/>
+        </a:xfrm>
+      </p:grpSpPr>
+      <p:sp>
+        <p:nvSpPr>
+          <p:cNvPr id="2" name="Slide Image Placeholder 1"/>
+          <p:cNvSpPr>
+            <a:spLocks noGrp="1"/>
+          </p:cNvSpPr>
+          <p:nvPr>
+            <p:ph type="sldImg" idx="2"/>
+          </p:nvPr>
+        </p:nvSpPr>
+        <p:spPr/>
+      </p:sp>
+      <p:sp>
+        <p:nvSpPr>
+          <p:cNvPr id="3" name="Notes Placeholder 2"/>
+          <p:cNvSpPr>
+            <a:spLocks noGrp="1"/>
+          </p:cNvSpPr>
+          <p:nvPr>
+            <p:ph type="body" idx="3" sz="quarter"/>
+          </p:nvPr>
+        </p:nvSpPr>
+        <p:spPr/>
+        <p:txBody>
+          <a:bodyPr wrap="square"/>
+          <a:lstStyle/>
+          <a:p>
+            <a:pPr>
+              <a:spcAft>
+                <a:spcPts val="800"/>
+              </a:spcAft>
+            </a:pPr>
+            <a:r>
+              <a:rPr sz="1200" b="0">
+                <a:solidFill>
+                  <a:srgbClr val="2A3B46"/>
+                </a:solidFill>
+                <a:latin typeface="Calibri"/>
+              </a:rPr>
+              <a:t>Use the table as a programme translation layer: need → secure-by-design response.</a:t>
+            </a:r>
+          </a:p>
+          <a:p>
+            <a:pPr>
+              <a:spcAft>
+                <a:spcPts val="800"/>
+              </a:spcAft>
+            </a:pPr>
+            <a:r>
+              <a:rPr sz="1200" b="0">
+                <a:solidFill>
+                  <a:srgbClr val="2A3B46"/>
+                </a:solidFill>
+                <a:latin typeface="Calibri"/>
+              </a:rPr>
+              <a:t>Highlight early detection of non-conforming code so controls can be placed calmly — not in a rush at go-live.</a:t>
+            </a:r>
+          </a:p>
+          <a:p>
+            <a:pPr>
+              <a:spcAft>
+                <a:spcPts val="800"/>
+              </a:spcAft>
+            </a:pPr>
+            <a:r>
+              <a:rPr sz="1200" b="0">
+                <a:solidFill>
+                  <a:srgbClr val="2A3B46"/>
+                </a:solidFill>
+                <a:latin typeface="Calibri"/>
+              </a:rPr>
+              <a:t>Close the slide on continuity: readable policies remain the design contract after the Dedicated move.</a:t>
+            </a:r>
+          </a:p>
+        </p:txBody>
+      </p:sp>
+      <p:sp>
+        <p:nvSpPr>
+          <p:cNvPr id="4" name="Slide Number Placeholder 3"/>
+          <p:cNvSpPr>
+            <a:spLocks noGrp="1"/>
+          </p:cNvSpPr>
+          <p:nvPr>
+            <p:ph type="sldNum" idx="5" sz="quarter"/>
+          </p:nvPr>
+        </p:nvSpPr>
+        <p:spPr/>
+      </p:sp>
+    </p:spTree>
+  </p:cSld>
+  <p:clrMapOvr>
+    <a:masterClrMapping/>
+  </p:clrMapOvr>
+</p:notes>
+</file>
+
+<file path=ppt/notesSlides/notesSlide11.xml><?xml version="1.0" encoding="utf-8"?>
+<p:notes xmlns:a="http://schemas.openxmlformats.org/drawingml/2006/main" xmlns:p="http://schemas.openxmlformats.org/presentationml/2006/main" xmlns:r="http://schemas.openxmlformats.org/officeDocument/2006/relationships">
+  <p:cSld>
+    <p:spTree>
+      <p:nvGrpSpPr>
+        <p:cNvPr id="1" name=""/>
+        <p:cNvGrpSpPr/>
+        <p:nvPr/>
+      </p:nvGrpSpPr>
+      <p:grpSpPr>
+        <a:xfrm>
+          <a:off x="0" y="0"/>
+          <a:ext cx="0" cy="0"/>
+          <a:chOff x="0" y="0"/>
+          <a:chExt cx="0" cy="0"/>
+        </a:xfrm>
+      </p:grpSpPr>
+      <p:sp>
+        <p:nvSpPr>
+          <p:cNvPr id="2" name="Slide Image Placeholder 1"/>
+          <p:cNvSpPr>
+            <a:spLocks noGrp="1"/>
+          </p:cNvSpPr>
+          <p:nvPr>
+            <p:ph type="sldImg" idx="2"/>
+          </p:nvPr>
+        </p:nvSpPr>
+        <p:spPr/>
+      </p:sp>
+      <p:sp>
+        <p:nvSpPr>
+          <p:cNvPr id="3" name="Notes Placeholder 2"/>
+          <p:cNvSpPr>
+            <a:spLocks noGrp="1"/>
+          </p:cNvSpPr>
+          <p:nvPr>
+            <p:ph type="body" idx="3" sz="quarter"/>
+          </p:nvPr>
+        </p:nvSpPr>
+        <p:spPr/>
+        <p:txBody>
+          <a:bodyPr wrap="square"/>
+          <a:lstStyle/>
+          <a:p>
+            <a:pPr>
+              <a:spcAft>
+                <a:spcPts val="800"/>
+              </a:spcAft>
+            </a:pPr>
+            <a:r>
+              <a:rPr sz="1200" b="0">
+                <a:solidFill>
+                  <a:srgbClr val="2A3B46"/>
+                </a:solidFill>
+                <a:latin typeface="Calibri"/>
+              </a:rPr>
+              <a:t>This is the success definition. Lead with identify and place controls.</a:t>
+            </a:r>
+          </a:p>
+          <a:p>
+            <a:pPr>
+              <a:spcAft>
+                <a:spcPts val="800"/>
+              </a:spcAft>
+            </a:pPr>
+            <a:r>
+              <a:rPr sz="1200" b="0">
+                <a:solidFill>
+                  <a:srgbClr val="2A3B46"/>
+                </a:solidFill>
+                <a:latin typeface="Calibri"/>
+              </a:rPr>
+              <a:t>Then: non-conformance is detected automatically; measurement is shared; priorities follow data; the same controls stay detectable after cutover.</a:t>
+            </a:r>
+          </a:p>
+          <a:p>
+            <a:pPr>
+              <a:spcAft>
+                <a:spcPts val="800"/>
+              </a:spcAft>
+            </a:pPr>
+            <a:r>
+              <a:rPr sz="1200" b="0">
+                <a:solidFill>
+                  <a:srgbClr val="2A3B46"/>
+                </a:solidFill>
+                <a:latin typeface="Calibri"/>
+              </a:rPr>
+              <a:t>Do not turn this into a people-performance story. It is a control-design story.</a:t>
+            </a:r>
+          </a:p>
+        </p:txBody>
+      </p:sp>
+      <p:sp>
+        <p:nvSpPr>
+          <p:cNvPr id="4" name="Slide Number Placeholder 3"/>
+          <p:cNvSpPr>
+            <a:spLocks noGrp="1"/>
+          </p:cNvSpPr>
+          <p:nvPr>
+            <p:ph type="sldNum" idx="5" sz="quarter"/>
+          </p:nvPr>
+        </p:nvSpPr>
+        <p:spPr/>
+      </p:sp>
+    </p:spTree>
+  </p:cSld>
+  <p:clrMapOvr>
+    <a:masterClrMapping/>
+  </p:clrMapOvr>
+</p:notes>
+</file>
+
+<file path=ppt/notesSlides/notesSlide12.xml><?xml version="1.0" encoding="utf-8"?>
+<p:notes xmlns:a="http://schemas.openxmlformats.org/drawingml/2006/main" xmlns:p="http://schemas.openxmlformats.org/presentationml/2006/main" xmlns:r="http://schemas.openxmlformats.org/officeDocument/2006/relationships">
+  <p:cSld>
+    <p:spTree>
+      <p:nvGrpSpPr>
+        <p:cNvPr id="1" name=""/>
+        <p:cNvGrpSpPr/>
+        <p:nvPr/>
+      </p:nvGrpSpPr>
+      <p:grpSpPr>
+        <a:xfrm>
+          <a:off x="0" y="0"/>
+          <a:ext cx="0" cy="0"/>
+          <a:chOff x="0" y="0"/>
+          <a:chExt cx="0" cy="0"/>
+        </a:xfrm>
+      </p:grpSpPr>
+      <p:sp>
+        <p:nvSpPr>
+          <p:cNvPr id="2" name="Slide Image Placeholder 1"/>
+          <p:cNvSpPr>
+            <a:spLocks noGrp="1"/>
+          </p:cNvSpPr>
+          <p:nvPr>
+            <p:ph type="sldImg" idx="2"/>
+          </p:nvPr>
+        </p:nvSpPr>
+        <p:spPr/>
+      </p:sp>
+      <p:sp>
+        <p:nvSpPr>
+          <p:cNvPr id="3" name="Notes Placeholder 2"/>
+          <p:cNvSpPr>
+            <a:spLocks noGrp="1"/>
+          </p:cNvSpPr>
+          <p:nvPr>
+            <p:ph type="body" idx="3" sz="quarter"/>
+          </p:nvPr>
+        </p:nvSpPr>
+        <p:spPr/>
+        <p:txBody>
+          <a:bodyPr wrap="square"/>
+          <a:lstStyle/>
+          <a:p>
+            <a:pPr>
+              <a:spcAft>
+                <a:spcPts val="800"/>
+              </a:spcAft>
+            </a:pPr>
+            <a:r>
+              <a:rPr sz="1200" b="0">
+                <a:solidFill>
+                  <a:srgbClr val="2A3B46"/>
+                </a:solidFill>
+                <a:latin typeface="Calibri"/>
+              </a:rPr>
+              <a:t>Close on secure by design in practice — five practical steps, not a leadership ask.</a:t>
+            </a:r>
+          </a:p>
+          <a:p>
+            <a:pPr>
+              <a:spcAft>
+                <a:spcPts val="800"/>
+              </a:spcAft>
+            </a:pPr>
+            <a:r>
+              <a:rPr sz="1200" b="0">
+                <a:solidFill>
+                  <a:srgbClr val="2A3B46"/>
+                </a:solidFill>
+                <a:latin typeface="Calibri"/>
+              </a:rPr>
+              <a:t>Repeat the punchline: what good looks like is controls identified and placed, with continuous detection of non-conformance.</a:t>
+            </a:r>
+          </a:p>
+          <a:p>
+            <a:pPr>
+              <a:spcAft>
+                <a:spcPts val="800"/>
+              </a:spcAft>
+            </a:pPr>
+            <a:r>
+              <a:rPr sz="1200" b="0">
+                <a:solidFill>
+                  <a:srgbClr val="2A3B46"/>
+                </a:solidFill>
+                <a:latin typeface="Calibri"/>
+              </a:rPr>
+              <a:t>Invite discussion on which control areas to baseline first for the Dedicated cohort and Nexus expectations.</a:t>
+            </a:r>
+          </a:p>
+        </p:txBody>
+      </p:sp>
+      <p:sp>
+        <p:nvSpPr>
+          <p:cNvPr id="4" name="Slide Number Placeholder 3"/>
+          <p:cNvSpPr>
+            <a:spLocks noGrp="1"/>
+          </p:cNvSpPr>
+          <p:nvPr>
+            <p:ph type="sldNum" idx="5" sz="quarter"/>
+          </p:nvPr>
+        </p:nvSpPr>
+        <p:spPr/>
+      </p:sp>
+    </p:spTree>
+  </p:cSld>
+  <p:clrMapOvr>
+    <a:masterClrMapping/>
+  </p:clrMapOvr>
+</p:notes>
+</file>
+
+<file path=ppt/notesSlides/notesSlide2.xml><?xml version="1.0" encoding="utf-8"?>
+<p:notes xmlns:a="http://schemas.openxmlformats.org/drawingml/2006/main" xmlns:p="http://schemas.openxmlformats.org/presentationml/2006/main" xmlns:r="http://schemas.openxmlformats.org/officeDocument/2006/relationships">
+  <p:cSld>
+    <p:spTree>
+      <p:nvGrpSpPr>
+        <p:cNvPr id="1" name=""/>
+        <p:cNvGrpSpPr/>
+        <p:nvPr/>
+      </p:nvGrpSpPr>
+      <p:grpSpPr>
+        <a:xfrm>
+          <a:off x="0" y="0"/>
+          <a:ext cx="0" cy="0"/>
+          <a:chOff x="0" y="0"/>
+          <a:chExt cx="0" cy="0"/>
+        </a:xfrm>
+      </p:grpSpPr>
+      <p:sp>
+        <p:nvSpPr>
+          <p:cNvPr id="2" name="Slide Image Placeholder 1"/>
+          <p:cNvSpPr>
+            <a:spLocks noGrp="1"/>
+          </p:cNvSpPr>
+          <p:nvPr>
+            <p:ph type="sldImg" idx="2"/>
+          </p:nvPr>
+        </p:nvSpPr>
+        <p:spPr/>
+      </p:sp>
+      <p:sp>
+        <p:nvSpPr>
+          <p:cNvPr id="3" name="Notes Placeholder 2"/>
+          <p:cNvSpPr>
+            <a:spLocks noGrp="1"/>
+          </p:cNvSpPr>
+          <p:nvPr>
+            <p:ph type="body" idx="3" sz="quarter"/>
+          </p:nvPr>
+        </p:nvSpPr>
+        <p:spPr/>
+        <p:txBody>
+          <a:bodyPr wrap="square"/>
+          <a:lstStyle/>
+          <a:p>
+            <a:pPr>
+              <a:spcAft>
+                <a:spcPts val="800"/>
+              </a:spcAft>
+            </a:pPr>
+            <a:r>
+              <a:rPr sz="1200" b="0">
+                <a:solidFill>
+                  <a:srgbClr val="2A3B46"/>
+                </a:solidFill>
+                <a:latin typeface="Calibri"/>
+              </a:rPr>
+              <a:t>Walk the agenda briefly. Promise outcomes, not tooling detail.</a:t>
+            </a:r>
+          </a:p>
+          <a:p>
+            <a:pPr>
+              <a:spcAft>
+                <a:spcPts val="800"/>
+              </a:spcAft>
+            </a:pPr>
+            <a:r>
+              <a:rPr sz="1200" b="0">
+                <a:solidFill>
+                  <a:srgbClr val="2A3B46"/>
+                </a:solidFill>
+                <a:latin typeface="Calibri"/>
+              </a:rPr>
+              <a:t>Signal the destination early: what good looks like is identifying and placing controls — with continuous measurement and detection afterwards.</a:t>
+            </a:r>
+          </a:p>
+        </p:txBody>
+      </p:sp>
+      <p:sp>
+        <p:nvSpPr>
+          <p:cNvPr id="4" name="Slide Number Placeholder 3"/>
+          <p:cNvSpPr>
+            <a:spLocks noGrp="1"/>
+          </p:cNvSpPr>
+          <p:nvPr>
+            <p:ph type="sldNum" idx="5" sz="quarter"/>
+          </p:nvPr>
+        </p:nvSpPr>
+        <p:spPr/>
+      </p:sp>
+    </p:spTree>
+  </p:cSld>
+  <p:clrMapOvr>
+    <a:masterClrMapping/>
+  </p:clrMapOvr>
+</p:notes>
+</file>
+
+<file path=ppt/notesSlides/notesSlide3.xml><?xml version="1.0" encoding="utf-8"?>
+<p:notes xmlns:a="http://schemas.openxmlformats.org/drawingml/2006/main" xmlns:p="http://schemas.openxmlformats.org/presentationml/2006/main" xmlns:r="http://schemas.openxmlformats.org/officeDocument/2006/relationships">
+  <p:cSld>
+    <p:spTree>
+      <p:nvGrpSpPr>
+        <p:cNvPr id="1" name=""/>
+        <p:cNvGrpSpPr/>
+        <p:nvPr/>
+      </p:nvGrpSpPr>
+      <p:grpSpPr>
+        <a:xfrm>
+          <a:off x="0" y="0"/>
+          <a:ext cx="0" cy="0"/>
+          <a:chOff x="0" y="0"/>
+          <a:chExt cx="0" cy="0"/>
+        </a:xfrm>
+      </p:grpSpPr>
+      <p:sp>
+        <p:nvSpPr>
+          <p:cNvPr id="2" name="Slide Image Placeholder 1"/>
+          <p:cNvSpPr>
+            <a:spLocks noGrp="1"/>
+          </p:cNvSpPr>
+          <p:nvPr>
+            <p:ph type="sldImg" idx="2"/>
+          </p:nvPr>
+        </p:nvSpPr>
+        <p:spPr/>
+      </p:sp>
+      <p:sp>
+        <p:nvSpPr>
+          <p:cNvPr id="3" name="Notes Placeholder 2"/>
+          <p:cNvSpPr>
+            <a:spLocks noGrp="1"/>
+          </p:cNvSpPr>
+          <p:nvPr>
+            <p:ph type="body" idx="3" sz="quarter"/>
+          </p:nvPr>
+        </p:nvSpPr>
+        <p:spPr/>
+        <p:txBody>
+          <a:bodyPr wrap="square"/>
+          <a:lstStyle/>
+          <a:p>
+            <a:pPr>
+              <a:spcAft>
+                <a:spcPts val="800"/>
+              </a:spcAft>
+            </a:pPr>
+            <a:r>
+              <a:rPr sz="1200" b="0">
+                <a:solidFill>
+                  <a:srgbClr val="2A3B46"/>
+                </a:solidFill>
+                <a:latin typeface="Calibri"/>
+              </a:rPr>
+              <a:t>Stay non-judgemental. The problem is missing measurement and late detection — not people ignoring standards.</a:t>
+            </a:r>
+          </a:p>
+          <a:p>
+            <a:pPr>
+              <a:spcAft>
+                <a:spcPts val="800"/>
+              </a:spcAft>
+            </a:pPr>
+            <a:r>
+              <a:rPr sz="1200" b="0">
+                <a:solidFill>
+                  <a:srgbClr val="2A3B46"/>
+                </a:solidFill>
+                <a:latin typeface="Calibri"/>
+              </a:rPr>
+              <a:t>Say explicitly: drift into non-conformance is usually unintentional. Without detection, we only discover it when change is expensive.</a:t>
+            </a:r>
+          </a:p>
+          <a:p>
+            <a:pPr>
+              <a:spcAft>
+                <a:spcPts val="800"/>
+              </a:spcAft>
+            </a:pPr>
+            <a:r>
+              <a:rPr sz="1200" b="0">
+                <a:solidFill>
+                  <a:srgbClr val="2A3B46"/>
+                </a:solidFill>
+                <a:latin typeface="Calibri"/>
+              </a:rPr>
+              <a:t>Transition: Dedicated and Nexus make this design gap visible and urgent.</a:t>
+            </a:r>
+          </a:p>
+        </p:txBody>
+      </p:sp>
+      <p:sp>
+        <p:nvSpPr>
+          <p:cNvPr id="4" name="Slide Number Placeholder 3"/>
+          <p:cNvSpPr>
+            <a:spLocks noGrp="1"/>
+          </p:cNvSpPr>
+          <p:nvPr>
+            <p:ph type="sldNum" idx="5" sz="quarter"/>
+          </p:nvPr>
+        </p:nvSpPr>
+        <p:spPr/>
+      </p:sp>
+    </p:spTree>
+  </p:cSld>
+  <p:clrMapOvr>
+    <a:masterClrMapping/>
+  </p:clrMapOvr>
+</p:notes>
+</file>
+
+<file path=ppt/notesSlides/notesSlide4.xml><?xml version="1.0" encoding="utf-8"?>
+<p:notes xmlns:a="http://schemas.openxmlformats.org/drawingml/2006/main" xmlns:p="http://schemas.openxmlformats.org/presentationml/2006/main" xmlns:r="http://schemas.openxmlformats.org/officeDocument/2006/relationships">
+  <p:cSld>
+    <p:spTree>
+      <p:nvGrpSpPr>
+        <p:cNvPr id="1" name=""/>
+        <p:cNvGrpSpPr/>
+        <p:nvPr/>
+      </p:nvGrpSpPr>
+      <p:grpSpPr>
+        <a:xfrm>
+          <a:off x="0" y="0"/>
+          <a:ext cx="0" cy="0"/>
+          <a:chOff x="0" y="0"/>
+          <a:chExt cx="0" cy="0"/>
+        </a:xfrm>
+      </p:grpSpPr>
+      <p:sp>
+        <p:nvSpPr>
+          <p:cNvPr id="2" name="Slide Image Placeholder 1"/>
+          <p:cNvSpPr>
+            <a:spLocks noGrp="1"/>
+          </p:cNvSpPr>
+          <p:nvPr>
+            <p:ph type="sldImg" idx="2"/>
+          </p:nvPr>
+        </p:nvSpPr>
+        <p:spPr/>
+      </p:sp>
+      <p:sp>
+        <p:nvSpPr>
+          <p:cNvPr id="3" name="Notes Placeholder 2"/>
+          <p:cNvSpPr>
+            <a:spLocks noGrp="1"/>
+          </p:cNvSpPr>
+          <p:nvPr>
+            <p:ph type="body" idx="3" sz="quarter"/>
+          </p:nvPr>
+        </p:nvSpPr>
+        <p:spPr/>
+        <p:txBody>
+          <a:bodyPr wrap="square"/>
+          <a:lstStyle/>
+          <a:p>
+            <a:pPr>
+              <a:spcAft>
+                <a:spcPts val="800"/>
+              </a:spcAft>
+            </a:pPr>
+            <a:r>
+              <a:rPr sz="1200" b="0">
+                <a:solidFill>
+                  <a:srgbClr val="2A3B46"/>
+                </a:solidFill>
+                <a:latin typeface="Calibri"/>
+              </a:rPr>
+              <a:t>Position Dedicated and Nexus as design moments — chances to build security in, not bolt it on after cutover.</a:t>
+            </a:r>
+          </a:p>
+          <a:p>
+            <a:pPr>
+              <a:spcAft>
+                <a:spcPts val="800"/>
+              </a:spcAft>
+            </a:pPr>
+            <a:r>
+              <a:rPr sz="1200" b="0">
+                <a:solidFill>
+                  <a:srgbClr val="2A3B46"/>
+                </a:solidFill>
+                <a:latin typeface="Calibri"/>
+              </a:rPr>
+              <a:t>Left: migration needs a measured baseline of controls before we move.</a:t>
+            </a:r>
+          </a:p>
+          <a:p>
+            <a:pPr>
+              <a:spcAft>
+                <a:spcPts val="800"/>
+              </a:spcAft>
+            </a:pPr>
+            <a:r>
+              <a:rPr sz="1200" b="0">
+                <a:solidFill>
+                  <a:srgbClr val="2A3B46"/>
+                </a:solidFill>
+                <a:latin typeface="Calibri"/>
+              </a:rPr>
+              <a:t>Right: Nexus needs detectable pinning and freshness controls, with evidence that those controls work.</a:t>
+            </a:r>
+          </a:p>
+          <a:p>
+            <a:pPr>
+              <a:spcAft>
+                <a:spcPts val="800"/>
+              </a:spcAft>
+            </a:pPr>
+            <a:r>
+              <a:rPr sz="1200" b="0">
+                <a:solidFill>
+                  <a:srgbClr val="2A3B46"/>
+                </a:solidFill>
+                <a:latin typeface="Calibri"/>
+              </a:rPr>
+              <a:t>Avoid ‘people must follow rules’ language — focus on placing measurable controls.</a:t>
+            </a:r>
+          </a:p>
+        </p:txBody>
+      </p:sp>
+      <p:sp>
+        <p:nvSpPr>
+          <p:cNvPr id="4" name="Slide Number Placeholder 3"/>
+          <p:cNvSpPr>
+            <a:spLocks noGrp="1"/>
+          </p:cNvSpPr>
+          <p:nvPr>
+            <p:ph type="sldNum" idx="5" sz="quarter"/>
+          </p:nvPr>
+        </p:nvSpPr>
+        <p:spPr/>
+      </p:sp>
+    </p:spTree>
+  </p:cSld>
+  <p:clrMapOvr>
+    <a:masterClrMapping/>
+  </p:clrMapOvr>
+</p:notes>
+</file>
+
+<file path=ppt/notesSlides/notesSlide5.xml><?xml version="1.0" encoding="utf-8"?>
+<p:notes xmlns:a="http://schemas.openxmlformats.org/drawingml/2006/main" xmlns:p="http://schemas.openxmlformats.org/presentationml/2006/main" xmlns:r="http://schemas.openxmlformats.org/officeDocument/2006/relationships">
+  <p:cSld>
+    <p:spTree>
+      <p:nvGrpSpPr>
+        <p:cNvPr id="1" name=""/>
+        <p:cNvGrpSpPr/>
+        <p:nvPr/>
+      </p:nvGrpSpPr>
+      <p:grpSpPr>
+        <a:xfrm>
+          <a:off x="0" y="0"/>
+          <a:ext cx="0" cy="0"/>
+          <a:chOff x="0" y="0"/>
+          <a:chExt cx="0" cy="0"/>
+        </a:xfrm>
+      </p:grpSpPr>
+      <p:sp>
+        <p:nvSpPr>
+          <p:cNvPr id="2" name="Slide Image Placeholder 1"/>
+          <p:cNvSpPr>
+            <a:spLocks noGrp="1"/>
+          </p:cNvSpPr>
+          <p:nvPr>
+            <p:ph type="sldImg" idx="2"/>
+          </p:nvPr>
+        </p:nvSpPr>
+        <p:spPr/>
+      </p:sp>
+      <p:sp>
+        <p:nvSpPr>
+          <p:cNvPr id="3" name="Notes Placeholder 2"/>
+          <p:cNvSpPr>
+            <a:spLocks noGrp="1"/>
+          </p:cNvSpPr>
+          <p:nvPr>
+            <p:ph type="body" idx="3" sz="quarter"/>
+          </p:nvPr>
+        </p:nvSpPr>
+        <p:spPr/>
+        <p:txBody>
+          <a:bodyPr wrap="square"/>
+          <a:lstStyle/>
+          <a:p>
+            <a:pPr>
+              <a:spcAft>
+                <a:spcPts val="800"/>
+              </a:spcAft>
+            </a:pPr>
+            <a:r>
+              <a:rPr sz="1200" b="0">
+                <a:solidFill>
+                  <a:srgbClr val="2A3B46"/>
+                </a:solidFill>
+                <a:latin typeface="Calibri"/>
+              </a:rPr>
+              <a:t>This is the capability story in business language.</a:t>
+            </a:r>
+          </a:p>
+          <a:p>
+            <a:pPr>
+              <a:spcAft>
+                <a:spcPts val="800"/>
+              </a:spcAft>
+            </a:pPr>
+            <a:r>
+              <a:rPr sz="1200" b="0">
+                <a:solidFill>
+                  <a:srgbClr val="2A3B46"/>
+                </a:solidFill>
+                <a:latin typeface="Calibri"/>
+              </a:rPr>
+              <a:t>Stress the sequence: measure → detect non-conforming code → place controls → guide behaviour with shared evidence.</a:t>
+            </a:r>
+          </a:p>
+          <a:p>
+            <a:pPr>
+              <a:spcAft>
+                <a:spcPts val="800"/>
+              </a:spcAft>
+            </a:pPr>
+            <a:r>
+              <a:rPr sz="1200" b="0">
+                <a:solidFill>
+                  <a:srgbClr val="2A3B46"/>
+                </a:solidFill>
+                <a:latin typeface="Calibri"/>
+              </a:rPr>
+              <a:t>Remind the room that detected non-conformance is usually drift, not intent. The tool creates early signals so we can act calmly.</a:t>
+            </a:r>
+          </a:p>
+        </p:txBody>
+      </p:sp>
+      <p:sp>
+        <p:nvSpPr>
+          <p:cNvPr id="4" name="Slide Number Placeholder 3"/>
+          <p:cNvSpPr>
+            <a:spLocks noGrp="1"/>
+          </p:cNvSpPr>
+          <p:nvPr>
+            <p:ph type="sldNum" idx="5" sz="quarter"/>
+          </p:nvPr>
+        </p:nvSpPr>
+        <p:spPr/>
+      </p:sp>
+    </p:spTree>
+  </p:cSld>
+  <p:clrMapOvr>
+    <a:masterClrMapping/>
+  </p:clrMapOvr>
+</p:notes>
+</file>
+
+<file path=ppt/notesSlides/notesSlide6.xml><?xml version="1.0" encoding="utf-8"?>
+<p:notes xmlns:a="http://schemas.openxmlformats.org/drawingml/2006/main" xmlns:p="http://schemas.openxmlformats.org/presentationml/2006/main" xmlns:r="http://schemas.openxmlformats.org/officeDocument/2006/relationships">
+  <p:cSld>
+    <p:spTree>
+      <p:nvGrpSpPr>
+        <p:cNvPr id="1" name=""/>
+        <p:cNvGrpSpPr/>
+        <p:nvPr/>
+      </p:nvGrpSpPr>
+      <p:grpSpPr>
+        <a:xfrm>
+          <a:off x="0" y="0"/>
+          <a:ext cx="0" cy="0"/>
+          <a:chOff x="0" y="0"/>
+          <a:chExt cx="0" cy="0"/>
+        </a:xfrm>
+      </p:grpSpPr>
+      <p:sp>
+        <p:nvSpPr>
+          <p:cNvPr id="2" name="Slide Image Placeholder 1"/>
+          <p:cNvSpPr>
+            <a:spLocks noGrp="1"/>
+          </p:cNvSpPr>
+          <p:nvPr>
+            <p:ph type="sldImg" idx="2"/>
+          </p:nvPr>
+        </p:nvSpPr>
+        <p:spPr/>
+      </p:sp>
+      <p:sp>
+        <p:nvSpPr>
+          <p:cNvPr id="3" name="Notes Placeholder 2"/>
+          <p:cNvSpPr>
+            <a:spLocks noGrp="1"/>
+          </p:cNvSpPr>
+          <p:nvPr>
+            <p:ph type="body" idx="3" sz="quarter"/>
+          </p:nvPr>
+        </p:nvSpPr>
+        <p:spPr/>
+        <p:txBody>
+          <a:bodyPr wrap="square"/>
+          <a:lstStyle/>
+          <a:p>
+            <a:pPr>
+              <a:spcAft>
+                <a:spcPts val="800"/>
+              </a:spcAft>
+            </a:pPr>
+            <a:r>
+              <a:rPr sz="1200" b="0">
+                <a:solidFill>
+                  <a:srgbClr val="2A3B46"/>
+                </a:solidFill>
+                <a:latin typeface="Calibri"/>
+              </a:rPr>
+              <a:t>Map each capability to a secure-by-design outcome without diving into commands.</a:t>
+            </a:r>
+          </a:p>
+          <a:p>
+            <a:pPr>
+              <a:spcAft>
+                <a:spcPts val="800"/>
+              </a:spcAft>
+            </a:pPr>
+            <a:r>
+              <a:rPr sz="1200" b="0">
+                <a:solidFill>
+                  <a:srgbClr val="2A3B46"/>
+                </a:solidFill>
+                <a:latin typeface="Calibri"/>
+              </a:rPr>
+              <a:t>Check = detect non-conformance. Scan = measure cohort coverage. Supply-chain = place Nexus-aligned controls. Document = keep control intent visible.</a:t>
+            </a:r>
+          </a:p>
+          <a:p>
+            <a:pPr>
+              <a:spcAft>
+                <a:spcPts val="800"/>
+              </a:spcAft>
+            </a:pPr>
+            <a:r>
+              <a:rPr sz="1200" b="0">
+                <a:solidFill>
+                  <a:srgbClr val="2A3B46"/>
+                </a:solidFill>
+                <a:latin typeface="Calibri"/>
+              </a:rPr>
+              <a:t>If asked for detail: these work from pipeline configuration and optional project settings — still keep the conversation on outcomes.</a:t>
+            </a:r>
+          </a:p>
+        </p:txBody>
+      </p:sp>
+      <p:sp>
+        <p:nvSpPr>
+          <p:cNvPr id="4" name="Slide Number Placeholder 3"/>
+          <p:cNvSpPr>
+            <a:spLocks noGrp="1"/>
+          </p:cNvSpPr>
+          <p:nvPr>
+            <p:ph type="sldNum" idx="5" sz="quarter"/>
+          </p:nvPr>
+        </p:nvSpPr>
+        <p:spPr/>
+      </p:sp>
+    </p:spTree>
+  </p:cSld>
+  <p:clrMapOvr>
+    <a:masterClrMapping/>
+  </p:clrMapOvr>
+</p:notes>
+</file>
+
+<file path=ppt/notesSlides/notesSlide7.xml><?xml version="1.0" encoding="utf-8"?>
+<p:notes xmlns:a="http://schemas.openxmlformats.org/drawingml/2006/main" xmlns:p="http://schemas.openxmlformats.org/presentationml/2006/main" xmlns:r="http://schemas.openxmlformats.org/officeDocument/2006/relationships">
+  <p:cSld>
+    <p:spTree>
+      <p:nvGrpSpPr>
+        <p:cNvPr id="1" name=""/>
+        <p:cNvGrpSpPr/>
+        <p:nvPr/>
+      </p:nvGrpSpPr>
+      <p:grpSpPr>
+        <a:xfrm>
+          <a:off x="0" y="0"/>
+          <a:ext cx="0" cy="0"/>
+          <a:chOff x="0" y="0"/>
+          <a:chExt cx="0" cy="0"/>
+        </a:xfrm>
+      </p:grpSpPr>
+      <p:sp>
+        <p:nvSpPr>
+          <p:cNvPr id="2" name="Slide Image Placeholder 1"/>
+          <p:cNvSpPr>
+            <a:spLocks noGrp="1"/>
+          </p:cNvSpPr>
+          <p:nvPr>
+            <p:ph type="sldImg" idx="2"/>
+          </p:nvPr>
+        </p:nvSpPr>
+        <p:spPr/>
+      </p:sp>
+      <p:sp>
+        <p:nvSpPr>
+          <p:cNvPr id="3" name="Notes Placeholder 2"/>
+          <p:cNvSpPr>
+            <a:spLocks noGrp="1"/>
+          </p:cNvSpPr>
+          <p:nvPr>
+            <p:ph type="body" idx="3" sz="quarter"/>
+          </p:nvPr>
+        </p:nvSpPr>
+        <p:spPr/>
+        <p:txBody>
+          <a:bodyPr wrap="square"/>
+          <a:lstStyle/>
+          <a:p>
+            <a:pPr>
+              <a:spcAft>
+                <a:spcPts val="800"/>
+              </a:spcAft>
+            </a:pPr>
+            <a:r>
+              <a:rPr sz="1200" b="0">
+                <a:solidFill>
+                  <a:srgbClr val="2A3B46"/>
+                </a:solidFill>
+                <a:latin typeface="Calibri"/>
+              </a:rPr>
+              <a:t>Use this as a control catalogue — where we identify and place protections.</a:t>
+            </a:r>
+          </a:p>
+          <a:p>
+            <a:pPr>
+              <a:spcAft>
+                <a:spcPts val="800"/>
+              </a:spcAft>
+            </a:pPr>
+            <a:r>
+              <a:rPr sz="1200" b="0">
+                <a:solidFill>
+                  <a:srgbClr val="2A3B46"/>
+                </a:solidFill>
+                <a:latin typeface="Calibri"/>
+              </a:rPr>
+              <a:t>For each card, say ‘this is a control we can define, detect against, and place’.</a:t>
+            </a:r>
+          </a:p>
+          <a:p>
+            <a:pPr>
+              <a:spcAft>
+                <a:spcPts val="800"/>
+              </a:spcAft>
+            </a:pPr>
+            <a:r>
+              <a:rPr sz="1200" b="0">
+                <a:solidFill>
+                  <a:srgbClr val="2A3B46"/>
+                </a:solidFill>
+                <a:latin typeface="Calibri"/>
+              </a:rPr>
+              <a:t>Tie trusted components and freshness to Nexus; tie release guards and patterns to predictable Dedicated cutover. Automated assurance means the control is checked continuously, not only written in guidance.</a:t>
+            </a:r>
+          </a:p>
+        </p:txBody>
+      </p:sp>
+      <p:sp>
+        <p:nvSpPr>
+          <p:cNvPr id="4" name="Slide Number Placeholder 3"/>
+          <p:cNvSpPr>
+            <a:spLocks noGrp="1"/>
+          </p:cNvSpPr>
+          <p:nvPr>
+            <p:ph type="sldNum" idx="5" sz="quarter"/>
+          </p:nvPr>
+        </p:nvSpPr>
+        <p:spPr/>
+      </p:sp>
+    </p:spTree>
+  </p:cSld>
+  <p:clrMapOvr>
+    <a:masterClrMapping/>
+  </p:clrMapOvr>
+</p:notes>
+</file>
+
+<file path=ppt/notesSlides/notesSlide8.xml><?xml version="1.0" encoding="utf-8"?>
+<p:notes xmlns:a="http://schemas.openxmlformats.org/drawingml/2006/main" xmlns:p="http://schemas.openxmlformats.org/presentationml/2006/main" xmlns:r="http://schemas.openxmlformats.org/officeDocument/2006/relationships">
+  <p:cSld>
+    <p:spTree>
+      <p:nvGrpSpPr>
+        <p:cNvPr id="1" name=""/>
+        <p:cNvGrpSpPr/>
+        <p:nvPr/>
+      </p:nvGrpSpPr>
+      <p:grpSpPr>
+        <a:xfrm>
+          <a:off x="0" y="0"/>
+          <a:ext cx="0" cy="0"/>
+          <a:chOff x="0" y="0"/>
+          <a:chExt cx="0" cy="0"/>
+        </a:xfrm>
+      </p:grpSpPr>
+      <p:sp>
+        <p:nvSpPr>
+          <p:cNvPr id="2" name="Slide Image Placeholder 1"/>
+          <p:cNvSpPr>
+            <a:spLocks noGrp="1"/>
+          </p:cNvSpPr>
+          <p:nvPr>
+            <p:ph type="sldImg" idx="2"/>
+          </p:nvPr>
+        </p:nvSpPr>
+        <p:spPr/>
+      </p:sp>
+      <p:sp>
+        <p:nvSpPr>
+          <p:cNvPr id="3" name="Notes Placeholder 2"/>
+          <p:cNvSpPr>
+            <a:spLocks noGrp="1"/>
+          </p:cNvSpPr>
+          <p:nvPr>
+            <p:ph type="body" idx="3" sz="quarter"/>
+          </p:nvPr>
+        </p:nvSpPr>
+        <p:spPr/>
+        <p:txBody>
+          <a:bodyPr wrap="square"/>
+          <a:lstStyle/>
+          <a:p>
+            <a:pPr>
+              <a:spcAft>
+                <a:spcPts val="800"/>
+              </a:spcAft>
+            </a:pPr>
+            <a:r>
+              <a:rPr sz="1200" b="0">
+                <a:solidFill>
+                  <a:srgbClr val="2A3B46"/>
+                </a:solidFill>
+                <a:latin typeface="Calibri"/>
+              </a:rPr>
+              <a:t>Walk the five steps as the programme path.</a:t>
+            </a:r>
+          </a:p>
+          <a:p>
+            <a:pPr>
+              <a:spcAft>
+                <a:spcPts val="800"/>
+              </a:spcAft>
+            </a:pPr>
+            <a:r>
+              <a:rPr sz="1200" b="0">
+                <a:solidFill>
+                  <a:srgbClr val="2A3B46"/>
+                </a:solidFill>
+                <a:latin typeface="Calibri"/>
+              </a:rPr>
+              <a:t>Identify → Prioritise → Place controls → Measure → Sustain.</a:t>
+            </a:r>
+          </a:p>
+          <a:p>
+            <a:pPr>
+              <a:spcAft>
+                <a:spcPts val="800"/>
+              </a:spcAft>
+            </a:pPr>
+            <a:r>
+              <a:rPr sz="1200" b="0">
+                <a:solidFill>
+                  <a:srgbClr val="2A3B46"/>
+                </a:solidFill>
+                <a:latin typeface="Calibri"/>
+              </a:rPr>
+              <a:t>Pause on ‘Place controls’ — that is the heart of what good looks like. Sustain matters so unintentional drift is still detected after Dedicated go-live.</a:t>
+            </a:r>
+          </a:p>
+        </p:txBody>
+      </p:sp>
+      <p:sp>
+        <p:nvSpPr>
+          <p:cNvPr id="4" name="Slide Number Placeholder 3"/>
+          <p:cNvSpPr>
+            <a:spLocks noGrp="1"/>
+          </p:cNvSpPr>
+          <p:nvPr>
+            <p:ph type="sldNum" idx="5" sz="quarter"/>
+          </p:nvPr>
+        </p:nvSpPr>
+        <p:spPr/>
+      </p:sp>
+    </p:spTree>
+  </p:cSld>
+  <p:clrMapOvr>
+    <a:masterClrMapping/>
+  </p:clrMapOvr>
+</p:notes>
+</file>
+
+<file path=ppt/notesSlides/notesSlide9.xml><?xml version="1.0" encoding="utf-8"?>
+<p:notes xmlns:a="http://schemas.openxmlformats.org/drawingml/2006/main" xmlns:p="http://schemas.openxmlformats.org/presentationml/2006/main" xmlns:r="http://schemas.openxmlformats.org/officeDocument/2006/relationships">
+  <p:cSld>
+    <p:spTree>
+      <p:nvGrpSpPr>
+        <p:cNvPr id="1" name=""/>
+        <p:cNvGrpSpPr/>
+        <p:nvPr/>
+      </p:nvGrpSpPr>
+      <p:grpSpPr>
+        <a:xfrm>
+          <a:off x="0" y="0"/>
+          <a:ext cx="0" cy="0"/>
+          <a:chOff x="0" y="0"/>
+          <a:chExt cx="0" cy="0"/>
+        </a:xfrm>
+      </p:grpSpPr>
+      <p:sp>
+        <p:nvSpPr>
+          <p:cNvPr id="2" name="Slide Image Placeholder 1"/>
+          <p:cNvSpPr>
+            <a:spLocks noGrp="1"/>
+          </p:cNvSpPr>
+          <p:nvPr>
+            <p:ph type="sldImg" idx="2"/>
+          </p:nvPr>
+        </p:nvSpPr>
+        <p:spPr/>
+      </p:sp>
+      <p:sp>
+        <p:nvSpPr>
+          <p:cNvPr id="3" name="Notes Placeholder 2"/>
+          <p:cNvSpPr>
+            <a:spLocks noGrp="1"/>
+          </p:cNvSpPr>
+          <p:nvPr>
+            <p:ph type="body" idx="3" sz="quarter"/>
+          </p:nvPr>
+        </p:nvSpPr>
+        <p:spPr/>
+        <p:txBody>
+          <a:bodyPr wrap="square"/>
+          <a:lstStyle/>
+          <a:p>
+            <a:pPr>
+              <a:spcAft>
+                <a:spcPts val="800"/>
+              </a:spcAft>
+            </a:pPr>
+            <a:r>
+              <a:rPr sz="1200" b="0">
+                <a:solidFill>
+                  <a:srgbClr val="2A3B46"/>
+                </a:solidFill>
+                <a:latin typeface="Calibri"/>
+              </a:rPr>
+              <a:t>Readable policies are how controls stay understandable after migration.</a:t>
+            </a:r>
+          </a:p>
+          <a:p>
+            <a:pPr>
+              <a:spcAft>
+                <a:spcPts val="800"/>
+              </a:spcAft>
+            </a:pPr>
+            <a:r>
+              <a:rPr sz="1200" b="0">
+                <a:solidFill>
+                  <a:srgbClr val="2A3B46"/>
+                </a:solidFill>
+                <a:latin typeface="Calibri"/>
+              </a:rPr>
+              <a:t>Read the example aloud. Then note: when the check fires, it usually means unintentional drift — a measurable signal that a control is not yet in place.</a:t>
+            </a:r>
+          </a:p>
+          <a:p>
+            <a:pPr>
+              <a:spcAft>
+                <a:spcPts val="800"/>
+              </a:spcAft>
+            </a:pPr>
+            <a:r>
+              <a:rPr sz="1200" b="0">
+                <a:solidFill>
+                  <a:srgbClr val="2A3B46"/>
+                </a:solidFill>
+                <a:latin typeface="Calibri"/>
+              </a:rPr>
+              <a:t>This is how security and delivery share one control definition without needing specialist decoding in every forum.</a:t>
+            </a:r>
+          </a:p>
+        </p:txBody>
+      </p:sp>
+      <p:sp>
+        <p:nvSpPr>
+          <p:cNvPr id="4" name="Slide Number Placeholder 3"/>
+          <p:cNvSpPr>
+            <a:spLocks noGrp="1"/>
+          </p:cNvSpPr>
+          <p:nvPr>
+            <p:ph type="sldNum" idx="5" sz="quarter"/>
+          </p:nvPr>
+        </p:nvSpPr>
+        <p:spPr/>
+      </p:sp>
+    </p:spTree>
+  </p:cSld>
+  <p:clrMapOvr>
+    <a:masterClrMapping/>
+  </p:clrMapOvr>
+</p:notes>
 </file>
 
 <file path=ppt/slideLayouts/slideLayout1.xml><?xml version="1.0" encoding="utf-8"?>
@@ -13202,4 +14908,324 @@
   </a:objectDefaults>
   <a:extraClrSchemeLst/>
 </a:theme>
+</file>
+
+<file path=ppt/theme/theme2.xml><?xml version="1.0" encoding="utf-8"?>
+<a:theme xmlns:a="http://schemas.openxmlformats.org/drawingml/2006/main" name="Office Theme">
+  <a:themeElements>
+    <a:clrScheme name="Office">
+      <a:dk1>
+        <a:sysClr val="windowText" lastClr="000000"/>
+      </a:dk1>
+      <a:lt1>
+        <a:sysClr val="window" lastClr="FFFFFF"/>
+      </a:lt1>
+      <a:dk2>
+        <a:srgbClr val="1F497D"/>
+      </a:dk2>
+      <a:lt2>
+        <a:srgbClr val="EEECE1"/>
+      </a:lt2>
+      <a:accent1>
+        <a:srgbClr val="4F81BD"/>
+      </a:accent1>
+      <a:accent2>
+        <a:srgbClr val="C0504D"/>
+      </a:accent2>
+      <a:accent3>
+        <a:srgbClr val="9BBB59"/>
+      </a:accent3>
+      <a:accent4>
+        <a:srgbClr val="8064A2"/>
+      </a:accent4>
+      <a:accent5>
+        <a:srgbClr val="4BACC6"/>
+      </a:accent5>
+      <a:accent6>
+        <a:srgbClr val="F79646"/>
+      </a:accent6>
+      <a:hlink>
+        <a:srgbClr val="0000FF"/>
+      </a:hlink>
+      <a:folHlink>
+        <a:srgbClr val="800080"/>
+      </a:folHlink>
+    </a:clrScheme>
+    <a:fontScheme name="Office">
+      <a:majorFont>
+        <a:latin typeface="Calibri"/>
+        <a:ea typeface=""/>
+        <a:cs typeface=""/>
+        <a:font script="Jpan" typeface="ＭＳ Ｐゴシック"/>
+        <a:font script="Hang" typeface="맑은 고딕"/>
+        <a:font script="Hans" typeface="宋体"/>
+        <a:font script="Hant" typeface="新細明體"/>
+        <a:font script="Arab" typeface="Times New Roman"/>
+        <a:font script="Hebr" typeface="Times New Roman"/>
+        <a:font script="Thai" typeface="Angsana New"/>
+        <a:font script="Ethi" typeface="Nyala"/>
+        <a:font script="Beng" typeface="Vrinda"/>
+        <a:font script="Gujr" typeface="Shruti"/>
+        <a:font script="Khmr" typeface="MoolBoran"/>
+        <a:font script="Knda" typeface="Tunga"/>
+        <a:font script="Guru" typeface="Raavi"/>
+        <a:font script="Cans" typeface="Euphemia"/>
+        <a:font script="Cher" typeface="Plantagenet Cherokee"/>
+        <a:font script="Yiii" typeface="Microsoft Yi Baiti"/>
+        <a:font script="Tibt" typeface="Microsoft Himalaya"/>
+        <a:font script="Thaa" typeface="MV Boli"/>
+        <a:font script="Deva" typeface="Mangal"/>
+        <a:font script="Telu" typeface="Gautami"/>
+        <a:font script="Taml" typeface="Latha"/>
+        <a:font script="Syrc" typeface="Estrangelo Edessa"/>
+        <a:font script="Orya" typeface="Kalinga"/>
+        <a:font script="Mlym" typeface="Kartika"/>
+        <a:font script="Laoo" typeface="DokChampa"/>
+        <a:font script="Sinh" typeface="Iskoola Pota"/>
+        <a:font script="Mong" typeface="Mongolian Baiti"/>
+        <a:font script="Viet" typeface="Times New Roman"/>
+        <a:font script="Uigh" typeface="Microsoft Uighur"/>
+        <a:font script="Geor" typeface="Sylfaen"/>
+      </a:majorFont>
+      <a:minorFont>
+        <a:latin typeface="Calibri"/>
+        <a:ea typeface=""/>
+        <a:cs typeface=""/>
+        <a:font script="Jpan" typeface="ＭＳ Ｐゴシック"/>
+        <a:font script="Hang" typeface="맑은 고딕"/>
+        <a:font script="Hans" typeface="宋体"/>
+        <a:font script="Hant" typeface="新細明體"/>
+        <a:font script="Arab" typeface="Arial"/>
+        <a:font script="Hebr" typeface="Arial"/>
+        <a:font script="Thai" typeface="Cordia New"/>
+        <a:font script="Ethi" typeface="Nyala"/>
+        <a:font script="Beng" typeface="Vrinda"/>
+        <a:font script="Gujr" typeface="Shruti"/>
+        <a:font script="Khmr" typeface="DaunPenh"/>
+        <a:font script="Knda" typeface="Tunga"/>
+        <a:font script="Guru" typeface="Raavi"/>
+        <a:font script="Cans" typeface="Euphemia"/>
+        <a:font script="Cher" typeface="Plantagenet Cherokee"/>
+        <a:font script="Yiii" typeface="Microsoft Yi Baiti"/>
+        <a:font script="Tibt" typeface="Microsoft Himalaya"/>
+        <a:font script="Thaa" typeface="MV Boli"/>
+        <a:font script="Deva" typeface="Mangal"/>
+        <a:font script="Telu" typeface="Gautami"/>
+        <a:font script="Taml" typeface="Latha"/>
+        <a:font script="Syrc" typeface="Estrangelo Edessa"/>
+        <a:font script="Orya" typeface="Kalinga"/>
+        <a:font script="Mlym" typeface="Kartika"/>
+        <a:font script="Laoo" typeface="DokChampa"/>
+        <a:font script="Sinh" typeface="Iskoola Pota"/>
+        <a:font script="Mong" typeface="Mongolian Baiti"/>
+        <a:font script="Viet" typeface="Arial"/>
+        <a:font script="Uigh" typeface="Microsoft Uighur"/>
+        <a:font script="Geor" typeface="Sylfaen"/>
+      </a:minorFont>
+    </a:fontScheme>
+    <a:fmtScheme name="Office">
+      <a:fillStyleLst>
+        <a:solidFill>
+          <a:schemeClr val="phClr"/>
+        </a:solidFill>
+        <a:gradFill rotWithShape="1">
+          <a:gsLst>
+            <a:gs pos="0">
+              <a:schemeClr val="phClr">
+                <a:tint val="50000"/>
+                <a:satMod val="300000"/>
+              </a:schemeClr>
+            </a:gs>
+            <a:gs pos="35000">
+              <a:schemeClr val="phClr">
+                <a:tint val="37000"/>
+                <a:satMod val="300000"/>
+              </a:schemeClr>
+            </a:gs>
+            <a:gs pos="100000">
+              <a:schemeClr val="phClr">
+                <a:tint val="15000"/>
+                <a:satMod val="350000"/>
+              </a:schemeClr>
+            </a:gs>
+          </a:gsLst>
+          <a:lin ang="16200000" scaled="1"/>
+        </a:gradFill>
+        <a:gradFill rotWithShape="1">
+          <a:gsLst>
+            <a:gs pos="0">
+              <a:schemeClr val="phClr">
+                <a:tint val="100000"/>
+                <a:shade val="100000"/>
+                <a:satMod val="130000"/>
+              </a:schemeClr>
+            </a:gs>
+            <a:gs pos="100000">
+              <a:schemeClr val="phClr">
+                <a:tint val="50000"/>
+                <a:shade val="100000"/>
+                <a:satMod val="350000"/>
+              </a:schemeClr>
+            </a:gs>
+          </a:gsLst>
+          <a:lin ang="16200000" scaled="0"/>
+        </a:gradFill>
+      </a:fillStyleLst>
+      <a:lnStyleLst>
+        <a:ln w="9525" cap="flat" cmpd="sng" algn="ctr">
+          <a:solidFill>
+            <a:schemeClr val="phClr">
+              <a:shade val="95000"/>
+              <a:satMod val="105000"/>
+            </a:schemeClr>
+          </a:solidFill>
+          <a:prstDash val="solid"/>
+        </a:ln>
+        <a:ln w="25400" cap="flat" cmpd="sng" algn="ctr">
+          <a:solidFill>
+            <a:schemeClr val="phClr"/>
+          </a:solidFill>
+          <a:prstDash val="solid"/>
+        </a:ln>
+        <a:ln w="38100" cap="flat" cmpd="sng" algn="ctr">
+          <a:solidFill>
+            <a:schemeClr val="phClr"/>
+          </a:solidFill>
+          <a:prstDash val="solid"/>
+        </a:ln>
+      </a:lnStyleLst>
+      <a:effectStyleLst>
+        <a:effectStyle>
+          <a:effectLst>
+            <a:outerShdw blurRad="40000" dist="20000" dir="5400000" rotWithShape="0">
+              <a:srgbClr val="000000">
+                <a:alpha val="38000"/>
+              </a:srgbClr>
+            </a:outerShdw>
+          </a:effectLst>
+        </a:effectStyle>
+        <a:effectStyle>
+          <a:effectLst>
+            <a:outerShdw blurRad="40000" dist="23000" dir="5400000" rotWithShape="0">
+              <a:srgbClr val="000000">
+                <a:alpha val="35000"/>
+              </a:srgbClr>
+            </a:outerShdw>
+          </a:effectLst>
+        </a:effectStyle>
+        <a:effectStyle>
+          <a:effectLst>
+            <a:outerShdw blurRad="40000" dist="23000" dir="5400000" rotWithShape="0">
+              <a:srgbClr val="000000">
+                <a:alpha val="35000"/>
+              </a:srgbClr>
+            </a:outerShdw>
+          </a:effectLst>
+          <a:scene3d>
+            <a:camera prst="orthographicFront">
+              <a:rot lat="0" lon="0" rev="0"/>
+            </a:camera>
+            <a:lightRig rig="threePt" dir="t">
+              <a:rot lat="0" lon="0" rev="1200000"/>
+            </a:lightRig>
+          </a:scene3d>
+          <a:sp3d>
+            <a:bevelT w="63500" h="25400"/>
+          </a:sp3d>
+        </a:effectStyle>
+      </a:effectStyleLst>
+      <a:bgFillStyleLst>
+        <a:solidFill>
+          <a:schemeClr val="phClr"/>
+        </a:solidFill>
+        <a:gradFill rotWithShape="1">
+          <a:gsLst>
+            <a:gs pos="0">
+              <a:schemeClr val="phClr">
+                <a:tint val="40000"/>
+                <a:satMod val="350000"/>
+              </a:schemeClr>
+            </a:gs>
+            <a:gs pos="40000">
+              <a:schemeClr val="phClr">
+                <a:tint val="45000"/>
+                <a:shade val="99000"/>
+                <a:satMod val="350000"/>
+              </a:schemeClr>
+            </a:gs>
+            <a:gs pos="100000">
+              <a:schemeClr val="phClr">
+                <a:shade val="20000"/>
+                <a:satMod val="255000"/>
+              </a:schemeClr>
+            </a:gs>
+          </a:gsLst>
+          <a:path path="circle">
+            <a:fillToRect l="50000" t="-80000" r="50000" b="180000"/>
+          </a:path>
+        </a:gradFill>
+        <a:gradFill rotWithShape="1">
+          <a:gsLst>
+            <a:gs pos="0">
+              <a:schemeClr val="phClr">
+                <a:tint val="80000"/>
+                <a:satMod val="300000"/>
+              </a:schemeClr>
+            </a:gs>
+            <a:gs pos="100000">
+              <a:schemeClr val="phClr">
+                <a:shade val="30000"/>
+                <a:satMod val="200000"/>
+              </a:schemeClr>
+            </a:gs>
+          </a:gsLst>
+          <a:path path="circle">
+            <a:fillToRect l="50000" t="50000" r="50000" b="50000"/>
+          </a:path>
+        </a:gradFill>
+      </a:bgFillStyleLst>
+    </a:fmtScheme>
+  </a:themeElements>
+  <a:objectDefaults>
+    <a:spDef>
+      <a:spPr/>
+      <a:bodyPr/>
+      <a:lstStyle/>
+      <a:style>
+        <a:lnRef idx="1">
+          <a:schemeClr val="accent1"/>
+        </a:lnRef>
+        <a:fillRef idx="3">
+          <a:schemeClr val="accent1"/>
+        </a:fillRef>
+        <a:effectRef idx="2">
+          <a:schemeClr val="accent1"/>
+        </a:effectRef>
+        <a:fontRef idx="minor">
+          <a:schemeClr val="lt1"/>
+        </a:fontRef>
+      </a:style>
+    </a:spDef>
+    <a:lnDef>
+      <a:spPr/>
+      <a:bodyPr/>
+      <a:lstStyle/>
+      <a:style>
+        <a:lnRef idx="2">
+          <a:schemeClr val="accent1"/>
+        </a:lnRef>
+        <a:fillRef idx="0">
+          <a:schemeClr val="accent1"/>
+        </a:fillRef>
+        <a:effectRef idx="1">
+          <a:schemeClr val="accent1"/>
+        </a:effectRef>
+        <a:fontRef idx="minor">
+          <a:schemeClr val="tx1"/>
+        </a:fontRef>
+      </a:style>
+    </a:lnDef>
+  </a:objectDefaults>
+  <a:extraClrSchemeLst/>
+</a:theme>
 </file>
</xml_diff>